<commit_message>
Corrections boussole + carte, mise à jour présentation, ajout scripts arbo
</commit_message>
<xml_diff>
--- a/documents/Presentation_JS.pptx
+++ b/documents/Presentation_JS.pptx
@@ -226,7 +226,7 @@
           <a:p>
             <a:fld id="{828A8F36-A643-4FAA-8649-965D6B1446A9}" type="datetimeFigureOut">
               <a:rPr lang="fr-FR" smtClean="0"/>
-              <a:t>19/12/2025</a:t>
+              <a:t>02/01/2026</a:t>
             </a:fld>
             <a:endParaRPr lang="fr-FR"/>
           </a:p>
@@ -403,7 +403,7 @@
           <a:p>
             <a:fld id="{2456FC83-ED93-4984-B7AA-3DB9F84FF409}" type="datetimeFigureOut">
               <a:rPr lang="fr-FR" smtClean="0"/>
-              <a:t>19/12/2025</a:t>
+              <a:t>02/01/2026</a:t>
             </a:fld>
             <a:endParaRPr lang="fr-FR"/>
           </a:p>
@@ -915,7 +915,7 @@
           <a:p>
             <a:fld id="{06137112-888A-40C4-BD31-96BD10D39A6F}" type="datetimeFigureOut">
               <a:rPr lang="fr-CH" smtClean="0"/>
-              <a:t>19.12.2025</a:t>
+              <a:t>02.01.2026</a:t>
             </a:fld>
             <a:endParaRPr lang="fr-CH"/>
           </a:p>
@@ -1115,7 +1115,7 @@
           <a:p>
             <a:fld id="{06137112-888A-40C4-BD31-96BD10D39A6F}" type="datetimeFigureOut">
               <a:rPr lang="fr-CH" smtClean="0"/>
-              <a:t>19.12.2025</a:t>
+              <a:t>02.01.2026</a:t>
             </a:fld>
             <a:endParaRPr lang="fr-CH"/>
           </a:p>
@@ -1325,7 +1325,7 @@
           <a:p>
             <a:fld id="{06137112-888A-40C4-BD31-96BD10D39A6F}" type="datetimeFigureOut">
               <a:rPr lang="fr-CH" smtClean="0"/>
-              <a:t>19.12.2025</a:t>
+              <a:t>02.01.2026</a:t>
             </a:fld>
             <a:endParaRPr lang="fr-CH"/>
           </a:p>
@@ -1525,7 +1525,7 @@
           <a:p>
             <a:fld id="{06137112-888A-40C4-BD31-96BD10D39A6F}" type="datetimeFigureOut">
               <a:rPr lang="fr-CH" smtClean="0"/>
-              <a:t>19.12.2025</a:t>
+              <a:t>02.01.2026</a:t>
             </a:fld>
             <a:endParaRPr lang="fr-CH"/>
           </a:p>
@@ -1801,7 +1801,7 @@
           <a:p>
             <a:fld id="{06137112-888A-40C4-BD31-96BD10D39A6F}" type="datetimeFigureOut">
               <a:rPr lang="fr-CH" smtClean="0"/>
-              <a:t>19.12.2025</a:t>
+              <a:t>02.01.2026</a:t>
             </a:fld>
             <a:endParaRPr lang="fr-CH"/>
           </a:p>
@@ -2069,7 +2069,7 @@
           <a:p>
             <a:fld id="{06137112-888A-40C4-BD31-96BD10D39A6F}" type="datetimeFigureOut">
               <a:rPr lang="fr-CH" smtClean="0"/>
-              <a:t>19.12.2025</a:t>
+              <a:t>02.01.2026</a:t>
             </a:fld>
             <a:endParaRPr lang="fr-CH"/>
           </a:p>
@@ -2484,7 +2484,7 @@
           <a:p>
             <a:fld id="{06137112-888A-40C4-BD31-96BD10D39A6F}" type="datetimeFigureOut">
               <a:rPr lang="fr-CH" smtClean="0"/>
-              <a:t>19.12.2025</a:t>
+              <a:t>02.01.2026</a:t>
             </a:fld>
             <a:endParaRPr lang="fr-CH"/>
           </a:p>
@@ -2626,7 +2626,7 @@
           <a:p>
             <a:fld id="{06137112-888A-40C4-BD31-96BD10D39A6F}" type="datetimeFigureOut">
               <a:rPr lang="fr-CH" smtClean="0"/>
-              <a:t>19.12.2025</a:t>
+              <a:t>02.01.2026</a:t>
             </a:fld>
             <a:endParaRPr lang="fr-CH"/>
           </a:p>
@@ -2739,7 +2739,7 @@
           <a:p>
             <a:fld id="{06137112-888A-40C4-BD31-96BD10D39A6F}" type="datetimeFigureOut">
               <a:rPr lang="fr-CH" smtClean="0"/>
-              <a:t>19.12.2025</a:t>
+              <a:t>02.01.2026</a:t>
             </a:fld>
             <a:endParaRPr lang="fr-CH"/>
           </a:p>
@@ -3052,7 +3052,7 @@
           <a:p>
             <a:fld id="{06137112-888A-40C4-BD31-96BD10D39A6F}" type="datetimeFigureOut">
               <a:rPr lang="fr-CH" smtClean="0"/>
-              <a:t>19.12.2025</a:t>
+              <a:t>02.01.2026</a:t>
             </a:fld>
             <a:endParaRPr lang="fr-CH"/>
           </a:p>
@@ -3341,7 +3341,7 @@
           <a:p>
             <a:fld id="{06137112-888A-40C4-BD31-96BD10D39A6F}" type="datetimeFigureOut">
               <a:rPr lang="fr-CH" smtClean="0"/>
-              <a:t>19.12.2025</a:t>
+              <a:t>02.01.2026</a:t>
             </a:fld>
             <a:endParaRPr lang="fr-CH"/>
           </a:p>
@@ -3593,7 +3593,7 @@
           <a:p>
             <a:fld id="{06137112-888A-40C4-BD31-96BD10D39A6F}" type="datetimeFigureOut">
               <a:rPr lang="fr-CH" smtClean="0"/>
-              <a:t>19.12.2025</a:t>
+              <a:t>02.01.2026</a:t>
             </a:fld>
             <a:endParaRPr lang="fr-CH"/>
           </a:p>
@@ -6262,7 +6262,7 @@
         </p:spPr>
         <p:txBody>
           <a:bodyPr vert="horz" lIns="91440" tIns="45720" rIns="91440" bIns="45720" rtlCol="0" anchor="b">
-            <a:normAutofit fontScale="92500"/>
+            <a:normAutofit/>
           </a:bodyPr>
           <a:lstStyle/>
           <a:p>
@@ -9261,6 +9261,222 @@
           </a:p>
         </p:txBody>
       </p:sp>
+      <p:pic>
+        <p:nvPicPr>
+          <p:cNvPr id="7" name="Image 6">
+            <a:extLst>
+              <a:ext uri="{FF2B5EF4-FFF2-40B4-BE49-F238E27FC236}">
+                <a16:creationId xmlns:a16="http://schemas.microsoft.com/office/drawing/2014/main" id="{70BD0F02-09CF-4313-8E33-9C10E694E3B3}"/>
+              </a:ext>
+            </a:extLst>
+          </p:cNvPr>
+          <p:cNvPicPr>
+            <a:picLocks noChangeAspect="1"/>
+          </p:cNvPicPr>
+          <p:nvPr/>
+        </p:nvPicPr>
+        <p:blipFill>
+          <a:blip r:embed="rId2">
+            <a:extLst>
+              <a:ext uri="{28A0092B-C50C-407E-A947-70E740481C1C}">
+                <a14:useLocalDpi xmlns:a14="http://schemas.microsoft.com/office/drawing/2010/main" val="0"/>
+              </a:ext>
+            </a:extLst>
+          </a:blip>
+          <a:stretch>
+            <a:fillRect/>
+          </a:stretch>
+        </p:blipFill>
+        <p:spPr>
+          <a:xfrm>
+            <a:off x="324829" y="1810344"/>
+            <a:ext cx="2122536" cy="3454064"/>
+          </a:xfrm>
+          <a:prstGeom prst="rect">
+            <a:avLst/>
+          </a:prstGeom>
+        </p:spPr>
+      </p:pic>
+      <p:pic>
+        <p:nvPicPr>
+          <p:cNvPr id="13" name="Image 12">
+            <a:extLst>
+              <a:ext uri="{FF2B5EF4-FFF2-40B4-BE49-F238E27FC236}">
+                <a16:creationId xmlns:a16="http://schemas.microsoft.com/office/drawing/2014/main" id="{15BEDDC1-876F-4322-8455-5FDD8B056D90}"/>
+              </a:ext>
+            </a:extLst>
+          </p:cNvPr>
+          <p:cNvPicPr>
+            <a:picLocks noChangeAspect="1"/>
+          </p:cNvPicPr>
+          <p:nvPr/>
+        </p:nvPicPr>
+        <p:blipFill>
+          <a:blip r:embed="rId3">
+            <a:extLst>
+              <a:ext uri="{28A0092B-C50C-407E-A947-70E740481C1C}">
+                <a14:useLocalDpi xmlns:a14="http://schemas.microsoft.com/office/drawing/2010/main" val="0"/>
+              </a:ext>
+            </a:extLst>
+          </a:blip>
+          <a:stretch>
+            <a:fillRect/>
+          </a:stretch>
+        </p:blipFill>
+        <p:spPr>
+          <a:xfrm>
+            <a:off x="2650009" y="303511"/>
+            <a:ext cx="2861361" cy="6250974"/>
+          </a:xfrm>
+          <a:prstGeom prst="rect">
+            <a:avLst/>
+          </a:prstGeom>
+        </p:spPr>
+      </p:pic>
+      <p:pic>
+        <p:nvPicPr>
+          <p:cNvPr id="15" name="Image 14">
+            <a:extLst>
+              <a:ext uri="{FF2B5EF4-FFF2-40B4-BE49-F238E27FC236}">
+                <a16:creationId xmlns:a16="http://schemas.microsoft.com/office/drawing/2014/main" id="{A2A39655-10C6-42C1-BC72-7639B2A6776A}"/>
+              </a:ext>
+            </a:extLst>
+          </p:cNvPr>
+          <p:cNvPicPr>
+            <a:picLocks noChangeAspect="1"/>
+          </p:cNvPicPr>
+          <p:nvPr/>
+        </p:nvPicPr>
+        <p:blipFill>
+          <a:blip r:embed="rId4">
+            <a:extLst>
+              <a:ext uri="{28A0092B-C50C-407E-A947-70E740481C1C}">
+                <a14:useLocalDpi xmlns:a14="http://schemas.microsoft.com/office/drawing/2010/main" val="0"/>
+              </a:ext>
+            </a:extLst>
+          </a:blip>
+          <a:stretch>
+            <a:fillRect/>
+          </a:stretch>
+        </p:blipFill>
+        <p:spPr>
+          <a:xfrm>
+            <a:off x="5587264" y="1238629"/>
+            <a:ext cx="2924583" cy="1505160"/>
+          </a:xfrm>
+          <a:prstGeom prst="rect">
+            <a:avLst/>
+          </a:prstGeom>
+        </p:spPr>
+      </p:pic>
+      <p:pic>
+        <p:nvPicPr>
+          <p:cNvPr id="17" name="Image 16">
+            <a:extLst>
+              <a:ext uri="{FF2B5EF4-FFF2-40B4-BE49-F238E27FC236}">
+                <a16:creationId xmlns:a16="http://schemas.microsoft.com/office/drawing/2014/main" id="{E82EB796-BACB-4C02-BE8D-2904617F7989}"/>
+              </a:ext>
+            </a:extLst>
+          </p:cNvPr>
+          <p:cNvPicPr>
+            <a:picLocks noChangeAspect="1"/>
+          </p:cNvPicPr>
+          <p:nvPr/>
+        </p:nvPicPr>
+        <p:blipFill>
+          <a:blip r:embed="rId5">
+            <a:extLst>
+              <a:ext uri="{28A0092B-C50C-407E-A947-70E740481C1C}">
+                <a14:useLocalDpi xmlns:a14="http://schemas.microsoft.com/office/drawing/2010/main" val="0"/>
+              </a:ext>
+            </a:extLst>
+          </a:blip>
+          <a:stretch>
+            <a:fillRect/>
+          </a:stretch>
+        </p:blipFill>
+        <p:spPr>
+          <a:xfrm>
+            <a:off x="5889539" y="2947122"/>
+            <a:ext cx="2324424" cy="1219370"/>
+          </a:xfrm>
+          <a:prstGeom prst="rect">
+            <a:avLst/>
+          </a:prstGeom>
+        </p:spPr>
+      </p:pic>
+      <p:pic>
+        <p:nvPicPr>
+          <p:cNvPr id="22" name="Image 21">
+            <a:extLst>
+              <a:ext uri="{FF2B5EF4-FFF2-40B4-BE49-F238E27FC236}">
+                <a16:creationId xmlns:a16="http://schemas.microsoft.com/office/drawing/2014/main" id="{B78DA315-E7D3-4BA8-8B40-F5FF14939628}"/>
+              </a:ext>
+            </a:extLst>
+          </p:cNvPr>
+          <p:cNvPicPr>
+            <a:picLocks noChangeAspect="1"/>
+          </p:cNvPicPr>
+          <p:nvPr/>
+        </p:nvPicPr>
+        <p:blipFill>
+          <a:blip r:embed="rId6">
+            <a:extLst>
+              <a:ext uri="{28A0092B-C50C-407E-A947-70E740481C1C}">
+                <a14:useLocalDpi xmlns:a14="http://schemas.microsoft.com/office/drawing/2010/main" val="0"/>
+              </a:ext>
+            </a:extLst>
+          </a:blip>
+          <a:stretch>
+            <a:fillRect/>
+          </a:stretch>
+        </p:blipFill>
+        <p:spPr>
+          <a:xfrm>
+            <a:off x="5596790" y="4748126"/>
+            <a:ext cx="2915057" cy="1247949"/>
+          </a:xfrm>
+          <a:prstGeom prst="rect">
+            <a:avLst/>
+          </a:prstGeom>
+        </p:spPr>
+      </p:pic>
+      <p:pic>
+        <p:nvPicPr>
+          <p:cNvPr id="28" name="Image 27">
+            <a:extLst>
+              <a:ext uri="{FF2B5EF4-FFF2-40B4-BE49-F238E27FC236}">
+                <a16:creationId xmlns:a16="http://schemas.microsoft.com/office/drawing/2014/main" id="{88FB63AE-ED32-436B-BAA0-0E7C06706C35}"/>
+              </a:ext>
+            </a:extLst>
+          </p:cNvPr>
+          <p:cNvPicPr>
+            <a:picLocks noChangeAspect="1"/>
+          </p:cNvPicPr>
+          <p:nvPr/>
+        </p:nvPicPr>
+        <p:blipFill>
+          <a:blip r:embed="rId7">
+            <a:extLst>
+              <a:ext uri="{28A0092B-C50C-407E-A947-70E740481C1C}">
+                <a14:useLocalDpi xmlns:a14="http://schemas.microsoft.com/office/drawing/2010/main" val="0"/>
+              </a:ext>
+            </a:extLst>
+          </a:blip>
+          <a:stretch>
+            <a:fillRect/>
+          </a:stretch>
+        </p:blipFill>
+        <p:spPr>
+          <a:xfrm>
+            <a:off x="8592133" y="343456"/>
+            <a:ext cx="3128591" cy="5755653"/>
+          </a:xfrm>
+          <a:prstGeom prst="rect">
+            <a:avLst/>
+          </a:prstGeom>
+        </p:spPr>
+      </p:pic>
     </p:spTree>
     <p:extLst>
       <p:ext uri="{BB962C8B-B14F-4D97-AF65-F5344CB8AC3E}">

</xml_diff>

<commit_message>
Commentaire sur le code et mise à jour de la présentation
</commit_message>
<xml_diff>
--- a/documents/Presentation_JS.pptx
+++ b/documents/Presentation_JS.pptx
@@ -15,10 +15,10 @@
     <p:sldId id="276" r:id="rId3"/>
     <p:sldId id="285" r:id="rId4"/>
     <p:sldId id="278" r:id="rId5"/>
-    <p:sldId id="279" r:id="rId6"/>
-    <p:sldId id="280" r:id="rId7"/>
-    <p:sldId id="290" r:id="rId8"/>
-    <p:sldId id="286" r:id="rId9"/>
+    <p:sldId id="280" r:id="rId6"/>
+    <p:sldId id="290" r:id="rId7"/>
+    <p:sldId id="286" r:id="rId8"/>
+    <p:sldId id="279" r:id="rId9"/>
     <p:sldId id="287" r:id="rId10"/>
     <p:sldId id="289" r:id="rId11"/>
     <p:sldId id="288" r:id="rId12"/>
@@ -226,7 +226,7 @@
           <a:p>
             <a:fld id="{828A8F36-A643-4FAA-8649-965D6B1446A9}" type="datetimeFigureOut">
               <a:rPr lang="fr-FR" smtClean="0"/>
-              <a:t>02/01/2026</a:t>
+              <a:t>04/01/2026</a:t>
             </a:fld>
             <a:endParaRPr lang="fr-FR"/>
           </a:p>
@@ -403,7 +403,7 @@
           <a:p>
             <a:fld id="{2456FC83-ED93-4984-B7AA-3DB9F84FF409}" type="datetimeFigureOut">
               <a:rPr lang="fr-FR" smtClean="0"/>
-              <a:t>02/01/2026</a:t>
+              <a:t>04/01/2026</a:t>
             </a:fld>
             <a:endParaRPr lang="fr-FR"/>
           </a:p>
@@ -714,19 +714,78 @@
           <a:bodyPr/>
           <a:lstStyle/>
           <a:p>
-            <a:r>
-              <a:rPr lang="fr-FR" dirty="0"/>
-              <a:t>Le fameux </a:t>
-            </a:r>
-            <a:r>
-              <a:rPr lang="fr-FR" b="1" dirty="0"/>
-              <a:t>POURQUOI</a:t>
-            </a:r>
-            <a:r>
-              <a:rPr lang="fr-FR" dirty="0"/>
-              <a:t> ?</a:t>
-            </a:r>
-            <a:endParaRPr lang="fr-CH" dirty="0"/>
+            <a:pPr marL="228600" indent="-228600">
+              <a:buAutoNum type="arabicPeriod"/>
+            </a:pPr>
+            <a:r>
+              <a:rPr lang="fr-CH" b="1" dirty="0">
+                <a:effectLst/>
+              </a:rPr>
+              <a:t>Introduction</a:t>
+            </a:r>
+          </a:p>
+          <a:p>
+            <a:pPr marL="0" indent="0">
+              <a:buNone/>
+            </a:pPr>
+            <a:endParaRPr lang="fr-CH" b="1" dirty="0">
+              <a:effectLst/>
+            </a:endParaRPr>
+          </a:p>
+          <a:p>
+            <a:r>
+              <a:rPr lang="fr-CH" dirty="0">
+                <a:effectLst/>
+              </a:rPr>
+              <a:t>Bienvenue à tous. </a:t>
+            </a:r>
+          </a:p>
+          <a:p>
+            <a:r>
+              <a:rPr lang="fr-CH" dirty="0">
+                <a:effectLst/>
+              </a:rPr>
+              <a:t>Aujourd’hui, on vous présente notre projet </a:t>
+            </a:r>
+            <a:r>
+              <a:rPr lang="fr-CH" dirty="0" err="1">
+                <a:effectLst/>
+              </a:rPr>
+              <a:t>SmartCockpit</a:t>
+            </a:r>
+            <a:r>
+              <a:rPr lang="fr-CH" dirty="0">
+                <a:effectLst/>
+              </a:rPr>
+              <a:t>, une solution JavaScript qui permet de suivre en temps réel les données d’un smartphone dans des environnements extrêmes. L’objectif : </a:t>
+            </a:r>
+          </a:p>
+          <a:p>
+            <a:pPr lvl="1"/>
+            <a:r>
+              <a:rPr lang="fr-CH" dirty="0">
+                <a:effectLst/>
+              </a:rPr>
+              <a:t>centraliser</a:t>
+            </a:r>
+          </a:p>
+          <a:p>
+            <a:pPr lvl="1"/>
+            <a:r>
+              <a:rPr lang="fr-CH" dirty="0">
+                <a:effectLst/>
+              </a:rPr>
+              <a:t> visualiser et exploiter les capteurs du téléphone à distance</a:t>
+            </a:r>
+          </a:p>
+          <a:p>
+            <a:pPr lvl="1"/>
+            <a:r>
+              <a:rPr lang="fr-CH" dirty="0">
+                <a:effectLst/>
+              </a:rPr>
+              <a:t>là où l’observation directe est impossible</a:t>
+            </a:r>
           </a:p>
         </p:txBody>
       </p:sp>
@@ -757,6 +816,1726 @@
     <p:extLst>
       <p:ext uri="{BB962C8B-B14F-4D97-AF65-F5344CB8AC3E}">
         <p14:creationId xmlns:p14="http://schemas.microsoft.com/office/powerpoint/2010/main" val="1984430122"/>
+      </p:ext>
+    </p:extLst>
+  </p:cSld>
+  <p:clrMapOvr>
+    <a:masterClrMapping/>
+  </p:clrMapOvr>
+</p:notes>
+</file>
+
+<file path=ppt/notesSlides/notesSlide10.xml><?xml version="1.0" encoding="utf-8"?>
+<p:notes xmlns:a="http://schemas.openxmlformats.org/drawingml/2006/main" xmlns:r="http://schemas.openxmlformats.org/officeDocument/2006/relationships" xmlns:p="http://schemas.openxmlformats.org/presentationml/2006/main">
+  <p:cSld>
+    <p:spTree>
+      <p:nvGrpSpPr>
+        <p:cNvPr id="1" name=""/>
+        <p:cNvGrpSpPr/>
+        <p:nvPr/>
+      </p:nvGrpSpPr>
+      <p:grpSpPr>
+        <a:xfrm>
+          <a:off x="0" y="0"/>
+          <a:ext cx="0" cy="0"/>
+          <a:chOff x="0" y="0"/>
+          <a:chExt cx="0" cy="0"/>
+        </a:xfrm>
+      </p:grpSpPr>
+      <p:sp>
+        <p:nvSpPr>
+          <p:cNvPr id="2" name="Espace réservé de l'image des diapositives 1"/>
+          <p:cNvSpPr>
+            <a:spLocks noGrp="1" noRot="1" noChangeAspect="1"/>
+          </p:cNvSpPr>
+          <p:nvPr>
+            <p:ph type="sldImg"/>
+          </p:nvPr>
+        </p:nvSpPr>
+        <p:spPr/>
+      </p:sp>
+      <p:sp>
+        <p:nvSpPr>
+          <p:cNvPr id="3" name="Espace réservé des notes 2"/>
+          <p:cNvSpPr>
+            <a:spLocks noGrp="1"/>
+          </p:cNvSpPr>
+          <p:nvPr>
+            <p:ph type="body" idx="1"/>
+          </p:nvPr>
+        </p:nvSpPr>
+        <p:spPr/>
+        <p:txBody>
+          <a:bodyPr/>
+          <a:lstStyle/>
+          <a:p>
+            <a:r>
+              <a:rPr lang="fr-CH" b="1" dirty="0">
+                <a:effectLst/>
+              </a:rPr>
+              <a:t>10. Perspectives d’évolution</a:t>
+            </a:r>
+          </a:p>
+          <a:p>
+            <a:endParaRPr lang="fr-CH" b="1" dirty="0">
+              <a:effectLst/>
+            </a:endParaRPr>
+          </a:p>
+          <a:p>
+            <a:r>
+              <a:rPr lang="fr-CH" dirty="0">
+                <a:effectLst/>
+              </a:rPr>
+              <a:t>Pour la suite, on envisage :</a:t>
+            </a:r>
+          </a:p>
+          <a:p>
+            <a:pPr lvl="1">
+              <a:buFont typeface="Arial" panose="020B0604020202020204" pitchFamily="34" charset="0"/>
+              <a:buChar char="•"/>
+            </a:pPr>
+            <a:r>
+              <a:rPr lang="fr-CH" dirty="0">
+                <a:effectLst/>
+              </a:rPr>
+              <a:t> d’ajouter plus de capteurs et widgets</a:t>
+            </a:r>
+          </a:p>
+          <a:p>
+            <a:pPr lvl="1">
+              <a:buFont typeface="Arial" panose="020B0604020202020204" pitchFamily="34" charset="0"/>
+              <a:buChar char="•"/>
+            </a:pPr>
+            <a:r>
+              <a:rPr lang="fr-CH" dirty="0">
+                <a:effectLst/>
+              </a:rPr>
+              <a:t> d’améliorer les interactions avec les widgets</a:t>
+            </a:r>
+          </a:p>
+          <a:p>
+            <a:pPr lvl="1">
+              <a:buFont typeface="Arial" panose="020B0604020202020204" pitchFamily="34" charset="0"/>
+              <a:buChar char="•"/>
+            </a:pPr>
+            <a:r>
+              <a:rPr lang="fr-CH" dirty="0">
+                <a:effectLst/>
+              </a:rPr>
+              <a:t> d’optimiser le flux de données</a:t>
+            </a:r>
+          </a:p>
+          <a:p>
+            <a:pPr lvl="1">
+              <a:buFont typeface="Arial" panose="020B0604020202020204" pitchFamily="34" charset="0"/>
+              <a:buChar char="•"/>
+            </a:pPr>
+            <a:r>
+              <a:rPr lang="fr-CH" dirty="0">
+                <a:effectLst/>
+              </a:rPr>
+              <a:t> d’ajouter un mode hors‑ligne et un historique des données Le cockpit peut évoluer vers une solution terrain complète</a:t>
+            </a:r>
+          </a:p>
+          <a:p>
+            <a:endParaRPr lang="fr-CH" dirty="0"/>
+          </a:p>
+        </p:txBody>
+      </p:sp>
+      <p:sp>
+        <p:nvSpPr>
+          <p:cNvPr id="4" name="Espace réservé du numéro de diapositive 3"/>
+          <p:cNvSpPr>
+            <a:spLocks noGrp="1"/>
+          </p:cNvSpPr>
+          <p:nvPr>
+            <p:ph type="sldNum" sz="quarter" idx="5"/>
+          </p:nvPr>
+        </p:nvSpPr>
+        <p:spPr/>
+        <p:txBody>
+          <a:bodyPr/>
+          <a:lstStyle/>
+          <a:p>
+            <a:fld id="{71653B15-6AAF-48C6-8ACB-6499FA667B64}" type="slidenum">
+              <a:rPr lang="fr-FR" smtClean="0"/>
+              <a:t>11</a:t>
+            </a:fld>
+            <a:endParaRPr lang="fr-FR"/>
+          </a:p>
+        </p:txBody>
+      </p:sp>
+    </p:spTree>
+    <p:extLst>
+      <p:ext uri="{BB962C8B-B14F-4D97-AF65-F5344CB8AC3E}">
+        <p14:creationId xmlns:p14="http://schemas.microsoft.com/office/powerpoint/2010/main" val="2519852892"/>
+      </p:ext>
+    </p:extLst>
+  </p:cSld>
+  <p:clrMapOvr>
+    <a:masterClrMapping/>
+  </p:clrMapOvr>
+</p:notes>
+</file>
+
+<file path=ppt/notesSlides/notesSlide11.xml><?xml version="1.0" encoding="utf-8"?>
+<p:notes xmlns:a="http://schemas.openxmlformats.org/drawingml/2006/main" xmlns:r="http://schemas.openxmlformats.org/officeDocument/2006/relationships" xmlns:p="http://schemas.openxmlformats.org/presentationml/2006/main">
+  <p:cSld>
+    <p:spTree>
+      <p:nvGrpSpPr>
+        <p:cNvPr id="1" name=""/>
+        <p:cNvGrpSpPr/>
+        <p:nvPr/>
+      </p:nvGrpSpPr>
+      <p:grpSpPr>
+        <a:xfrm>
+          <a:off x="0" y="0"/>
+          <a:ext cx="0" cy="0"/>
+          <a:chOff x="0" y="0"/>
+          <a:chExt cx="0" cy="0"/>
+        </a:xfrm>
+      </p:grpSpPr>
+      <p:sp>
+        <p:nvSpPr>
+          <p:cNvPr id="2" name="Espace réservé de l'image des diapositives 1"/>
+          <p:cNvSpPr>
+            <a:spLocks noGrp="1" noRot="1" noChangeAspect="1"/>
+          </p:cNvSpPr>
+          <p:nvPr>
+            <p:ph type="sldImg"/>
+          </p:nvPr>
+        </p:nvSpPr>
+        <p:spPr/>
+      </p:sp>
+      <p:sp>
+        <p:nvSpPr>
+          <p:cNvPr id="3" name="Espace réservé des notes 2"/>
+          <p:cNvSpPr>
+            <a:spLocks noGrp="1"/>
+          </p:cNvSpPr>
+          <p:nvPr>
+            <p:ph type="body" idx="1"/>
+          </p:nvPr>
+        </p:nvSpPr>
+        <p:spPr/>
+        <p:txBody>
+          <a:bodyPr/>
+          <a:lstStyle/>
+          <a:p>
+            <a:endParaRPr lang="fr-CH" dirty="0"/>
+          </a:p>
+        </p:txBody>
+      </p:sp>
+      <p:sp>
+        <p:nvSpPr>
+          <p:cNvPr id="4" name="Espace réservé du numéro de diapositive 3"/>
+          <p:cNvSpPr>
+            <a:spLocks noGrp="1"/>
+          </p:cNvSpPr>
+          <p:nvPr>
+            <p:ph type="sldNum" sz="quarter" idx="5"/>
+          </p:nvPr>
+        </p:nvSpPr>
+        <p:spPr/>
+        <p:txBody>
+          <a:bodyPr/>
+          <a:lstStyle/>
+          <a:p>
+            <a:fld id="{71653B15-6AAF-48C6-8ACB-6499FA667B64}" type="slidenum">
+              <a:rPr lang="fr-FR" smtClean="0"/>
+              <a:t>12</a:t>
+            </a:fld>
+            <a:endParaRPr lang="fr-FR"/>
+          </a:p>
+        </p:txBody>
+      </p:sp>
+    </p:spTree>
+    <p:extLst>
+      <p:ext uri="{BB962C8B-B14F-4D97-AF65-F5344CB8AC3E}">
+        <p14:creationId xmlns:p14="http://schemas.microsoft.com/office/powerpoint/2010/main" val="3096406260"/>
+      </p:ext>
+    </p:extLst>
+  </p:cSld>
+  <p:clrMapOvr>
+    <a:masterClrMapping/>
+  </p:clrMapOvr>
+</p:notes>
+</file>
+
+<file path=ppt/notesSlides/notesSlide2.xml><?xml version="1.0" encoding="utf-8"?>
+<p:notes xmlns:a="http://schemas.openxmlformats.org/drawingml/2006/main" xmlns:r="http://schemas.openxmlformats.org/officeDocument/2006/relationships" xmlns:p="http://schemas.openxmlformats.org/presentationml/2006/main">
+  <p:cSld>
+    <p:spTree>
+      <p:nvGrpSpPr>
+        <p:cNvPr id="1" name=""/>
+        <p:cNvGrpSpPr/>
+        <p:nvPr/>
+      </p:nvGrpSpPr>
+      <p:grpSpPr>
+        <a:xfrm>
+          <a:off x="0" y="0"/>
+          <a:ext cx="0" cy="0"/>
+          <a:chOff x="0" y="0"/>
+          <a:chExt cx="0" cy="0"/>
+        </a:xfrm>
+      </p:grpSpPr>
+      <p:sp>
+        <p:nvSpPr>
+          <p:cNvPr id="2" name="Espace réservé de l'image des diapositives 1"/>
+          <p:cNvSpPr>
+            <a:spLocks noGrp="1" noRot="1" noChangeAspect="1"/>
+          </p:cNvSpPr>
+          <p:nvPr>
+            <p:ph type="sldImg"/>
+          </p:nvPr>
+        </p:nvSpPr>
+        <p:spPr/>
+      </p:sp>
+      <p:sp>
+        <p:nvSpPr>
+          <p:cNvPr id="3" name="Espace réservé des notes 2"/>
+          <p:cNvSpPr>
+            <a:spLocks noGrp="1"/>
+          </p:cNvSpPr>
+          <p:nvPr>
+            <p:ph type="body" idx="1"/>
+          </p:nvPr>
+        </p:nvSpPr>
+        <p:spPr/>
+        <p:txBody>
+          <a:bodyPr/>
+          <a:lstStyle/>
+          <a:p>
+            <a:r>
+              <a:rPr lang="fr-CH" b="1" dirty="0">
+                <a:effectLst/>
+              </a:rPr>
+              <a:t>2. Exemples de besoins couverts</a:t>
+            </a:r>
+          </a:p>
+          <a:p>
+            <a:endParaRPr lang="fr-CH" b="1" dirty="0">
+              <a:effectLst/>
+            </a:endParaRPr>
+          </a:p>
+          <a:p>
+            <a:r>
+              <a:rPr lang="fr-CH" dirty="0">
+                <a:effectLst/>
+              </a:rPr>
+              <a:t>Voici quelques cas concrets où notre solution est utile : </a:t>
+            </a:r>
+          </a:p>
+          <a:p>
+            <a:endParaRPr lang="fr-CH" dirty="0">
+              <a:effectLst/>
+            </a:endParaRPr>
+          </a:p>
+          <a:p>
+            <a:pPr lvl="1">
+              <a:buFont typeface="Arial" panose="020B0604020202020204" pitchFamily="34" charset="0"/>
+              <a:buChar char="•"/>
+            </a:pPr>
+            <a:r>
+              <a:rPr lang="fr-CH" dirty="0">
+                <a:effectLst/>
+              </a:rPr>
+              <a:t> suivi d’un drone, d’un skieur</a:t>
+            </a:r>
+          </a:p>
+          <a:p>
+            <a:pPr marL="457200" marR="0" lvl="1" indent="0" algn="l" defTabSz="914400" rtl="0" eaLnBrk="1" fontAlgn="auto" latinLnBrk="0" hangingPunct="1">
+              <a:lnSpc>
+                <a:spcPct val="100000"/>
+              </a:lnSpc>
+              <a:spcBef>
+                <a:spcPts val="0"/>
+              </a:spcBef>
+              <a:spcAft>
+                <a:spcPts val="0"/>
+              </a:spcAft>
+              <a:buClrTx/>
+              <a:buSzTx/>
+              <a:buFont typeface="Arial" panose="020B0604020202020204" pitchFamily="34" charset="0"/>
+              <a:buChar char="•"/>
+              <a:tabLst/>
+              <a:defRPr/>
+            </a:pPr>
+            <a:r>
+              <a:rPr lang="fr-CH" dirty="0">
+                <a:effectLst/>
+              </a:rPr>
+              <a:t> d’un parapentiste</a:t>
+            </a:r>
+          </a:p>
+          <a:p>
+            <a:pPr marL="457200" marR="0" lvl="1" indent="0" algn="l" defTabSz="914400" rtl="0" eaLnBrk="1" fontAlgn="auto" latinLnBrk="0" hangingPunct="1">
+              <a:lnSpc>
+                <a:spcPct val="100000"/>
+              </a:lnSpc>
+              <a:spcBef>
+                <a:spcPts val="0"/>
+              </a:spcBef>
+              <a:spcAft>
+                <a:spcPts val="0"/>
+              </a:spcAft>
+              <a:buClrTx/>
+              <a:buSzTx/>
+              <a:buFont typeface="Arial" panose="020B0604020202020204" pitchFamily="34" charset="0"/>
+              <a:buChar char="•"/>
+              <a:tabLst/>
+              <a:defRPr/>
+            </a:pPr>
+            <a:r>
+              <a:rPr lang="fr-CH" dirty="0">
+                <a:effectLst/>
+              </a:rPr>
+              <a:t> d’un bateau en mer</a:t>
+            </a:r>
+          </a:p>
+          <a:p>
+            <a:pPr lvl="1">
+              <a:buFont typeface="Arial" panose="020B0604020202020204" pitchFamily="34" charset="0"/>
+              <a:buChar char="•"/>
+            </a:pPr>
+            <a:endParaRPr lang="fr-CH" dirty="0">
+              <a:effectLst/>
+            </a:endParaRPr>
+          </a:p>
+          <a:p>
+            <a:endParaRPr lang="fr-CH" dirty="0">
+              <a:effectLst/>
+            </a:endParaRPr>
+          </a:p>
+        </p:txBody>
+      </p:sp>
+      <p:sp>
+        <p:nvSpPr>
+          <p:cNvPr id="4" name="Espace réservé du numéro de diapositive 3"/>
+          <p:cNvSpPr>
+            <a:spLocks noGrp="1"/>
+          </p:cNvSpPr>
+          <p:nvPr>
+            <p:ph type="sldNum" sz="quarter" idx="5"/>
+          </p:nvPr>
+        </p:nvSpPr>
+        <p:spPr/>
+        <p:txBody>
+          <a:bodyPr/>
+          <a:lstStyle/>
+          <a:p>
+            <a:fld id="{71653B15-6AAF-48C6-8ACB-6499FA667B64}" type="slidenum">
+              <a:rPr lang="fr-FR" smtClean="0"/>
+              <a:t>3</a:t>
+            </a:fld>
+            <a:endParaRPr lang="fr-FR"/>
+          </a:p>
+        </p:txBody>
+      </p:sp>
+    </p:spTree>
+    <p:extLst>
+      <p:ext uri="{BB962C8B-B14F-4D97-AF65-F5344CB8AC3E}">
+        <p14:creationId xmlns:p14="http://schemas.microsoft.com/office/powerpoint/2010/main" val="2872589628"/>
+      </p:ext>
+    </p:extLst>
+  </p:cSld>
+  <p:clrMapOvr>
+    <a:masterClrMapping/>
+  </p:clrMapOvr>
+</p:notes>
+</file>
+
+<file path=ppt/notesSlides/notesSlide3.xml><?xml version="1.0" encoding="utf-8"?>
+<p:notes xmlns:a="http://schemas.openxmlformats.org/drawingml/2006/main" xmlns:r="http://schemas.openxmlformats.org/officeDocument/2006/relationships" xmlns:p="http://schemas.openxmlformats.org/presentationml/2006/main">
+  <p:cSld>
+    <p:spTree>
+      <p:nvGrpSpPr>
+        <p:cNvPr id="1" name=""/>
+        <p:cNvGrpSpPr/>
+        <p:nvPr/>
+      </p:nvGrpSpPr>
+      <p:grpSpPr>
+        <a:xfrm>
+          <a:off x="0" y="0"/>
+          <a:ext cx="0" cy="0"/>
+          <a:chOff x="0" y="0"/>
+          <a:chExt cx="0" cy="0"/>
+        </a:xfrm>
+      </p:grpSpPr>
+      <p:sp>
+        <p:nvSpPr>
+          <p:cNvPr id="2" name="Espace réservé de l'image des diapositives 1"/>
+          <p:cNvSpPr>
+            <a:spLocks noGrp="1" noRot="1" noChangeAspect="1"/>
+          </p:cNvSpPr>
+          <p:nvPr>
+            <p:ph type="sldImg"/>
+          </p:nvPr>
+        </p:nvSpPr>
+        <p:spPr/>
+      </p:sp>
+      <p:sp>
+        <p:nvSpPr>
+          <p:cNvPr id="3" name="Espace réservé des notes 2"/>
+          <p:cNvSpPr>
+            <a:spLocks noGrp="1"/>
+          </p:cNvSpPr>
+          <p:nvPr>
+            <p:ph type="body" idx="1"/>
+          </p:nvPr>
+        </p:nvSpPr>
+        <p:spPr/>
+        <p:txBody>
+          <a:bodyPr/>
+          <a:lstStyle/>
+          <a:p>
+            <a:r>
+              <a:rPr lang="fr-CH" b="1" dirty="0">
+                <a:effectLst/>
+              </a:rPr>
+              <a:t>3. Concept du projet</a:t>
+            </a:r>
+          </a:p>
+          <a:p>
+            <a:endParaRPr lang="fr-CH" b="1" dirty="0">
+              <a:effectLst/>
+            </a:endParaRPr>
+          </a:p>
+          <a:p>
+            <a:r>
+              <a:rPr lang="fr-CH" dirty="0">
+                <a:effectLst/>
+              </a:rPr>
+              <a:t>Ce slide résume le cœur du projet : </a:t>
+            </a:r>
+          </a:p>
+          <a:p>
+            <a:r>
+              <a:rPr lang="fr-CH" dirty="0">
+                <a:effectLst/>
+              </a:rPr>
+              <a:t>	collecter les données des capteurs d’un smartphone Android et les transmettre en temps réel vers une interface web. </a:t>
+            </a:r>
+          </a:p>
+          <a:p>
+            <a:r>
+              <a:rPr lang="fr-CH" dirty="0">
+                <a:effectLst/>
+              </a:rPr>
+              <a:t>	L’utilisateur appuie sur ‘START’ sur le téléphone, et les données </a:t>
+            </a:r>
+          </a:p>
+          <a:p>
+            <a:r>
+              <a:rPr lang="fr-CH" dirty="0">
+                <a:effectLst/>
+              </a:rPr>
+              <a:t>		— GPS, orientation, micro, caméra, etc. </a:t>
+            </a:r>
+          </a:p>
+          <a:p>
+            <a:r>
+              <a:rPr lang="fr-CH" dirty="0">
+                <a:effectLst/>
+              </a:rPr>
+              <a:t>		— sont envoyées via </a:t>
+            </a:r>
+            <a:r>
+              <a:rPr lang="fr-CH" dirty="0" err="1">
+                <a:effectLst/>
+              </a:rPr>
+              <a:t>WebSocket</a:t>
+            </a:r>
+            <a:r>
+              <a:rPr lang="fr-CH" dirty="0">
+                <a:effectLst/>
+              </a:rPr>
+              <a:t> à notre serveur Node.js hébergé sur Render.com.. </a:t>
+            </a:r>
+          </a:p>
+          <a:p>
+            <a:endParaRPr lang="fr-CH" dirty="0">
+              <a:effectLst/>
+            </a:endParaRPr>
+          </a:p>
+          <a:p>
+            <a:r>
+              <a:rPr lang="fr-CH" dirty="0">
+                <a:effectLst/>
+              </a:rPr>
+              <a:t>Ensuite, elles sont affichées sous forme de widgets dans notre cockpit de supervision. </a:t>
+            </a:r>
+          </a:p>
+          <a:p>
+            <a:endParaRPr lang="fr-CH" dirty="0">
+              <a:effectLst/>
+            </a:endParaRPr>
+          </a:p>
+          <a:p>
+            <a:r>
+              <a:rPr lang="fr-CH" dirty="0">
+                <a:effectLst/>
+              </a:rPr>
+              <a:t>Ce concept nous permet de suivre des activités mobiles à distance, avec une interface claire, modulaire et réactive.</a:t>
+            </a:r>
+          </a:p>
+          <a:p>
+            <a:endParaRPr lang="fr-CH" dirty="0"/>
+          </a:p>
+        </p:txBody>
+      </p:sp>
+      <p:sp>
+        <p:nvSpPr>
+          <p:cNvPr id="4" name="Espace réservé du numéro de diapositive 3"/>
+          <p:cNvSpPr>
+            <a:spLocks noGrp="1"/>
+          </p:cNvSpPr>
+          <p:nvPr>
+            <p:ph type="sldNum" sz="quarter" idx="5"/>
+          </p:nvPr>
+        </p:nvSpPr>
+        <p:spPr/>
+        <p:txBody>
+          <a:bodyPr/>
+          <a:lstStyle/>
+          <a:p>
+            <a:fld id="{71653B15-6AAF-48C6-8ACB-6499FA667B64}" type="slidenum">
+              <a:rPr lang="fr-FR" smtClean="0"/>
+              <a:t>4</a:t>
+            </a:fld>
+            <a:endParaRPr lang="fr-FR"/>
+          </a:p>
+        </p:txBody>
+      </p:sp>
+    </p:spTree>
+    <p:extLst>
+      <p:ext uri="{BB962C8B-B14F-4D97-AF65-F5344CB8AC3E}">
+        <p14:creationId xmlns:p14="http://schemas.microsoft.com/office/powerpoint/2010/main" val="3277561093"/>
+      </p:ext>
+    </p:extLst>
+  </p:cSld>
+  <p:clrMapOvr>
+    <a:masterClrMapping/>
+  </p:clrMapOvr>
+</p:notes>
+</file>
+
+<file path=ppt/notesSlides/notesSlide4.xml><?xml version="1.0" encoding="utf-8"?>
+<p:notes xmlns:a="http://schemas.openxmlformats.org/drawingml/2006/main" xmlns:r="http://schemas.openxmlformats.org/officeDocument/2006/relationships" xmlns:p="http://schemas.openxmlformats.org/presentationml/2006/main">
+  <p:cSld>
+    <p:spTree>
+      <p:nvGrpSpPr>
+        <p:cNvPr id="1" name=""/>
+        <p:cNvGrpSpPr/>
+        <p:nvPr/>
+      </p:nvGrpSpPr>
+      <p:grpSpPr>
+        <a:xfrm>
+          <a:off x="0" y="0"/>
+          <a:ext cx="0" cy="0"/>
+          <a:chOff x="0" y="0"/>
+          <a:chExt cx="0" cy="0"/>
+        </a:xfrm>
+      </p:grpSpPr>
+      <p:sp>
+        <p:nvSpPr>
+          <p:cNvPr id="2" name="Espace réservé de l'image des diapositives 1"/>
+          <p:cNvSpPr>
+            <a:spLocks noGrp="1" noRot="1" noChangeAspect="1"/>
+          </p:cNvSpPr>
+          <p:nvPr>
+            <p:ph type="sldImg"/>
+          </p:nvPr>
+        </p:nvSpPr>
+        <p:spPr/>
+      </p:sp>
+      <p:sp>
+        <p:nvSpPr>
+          <p:cNvPr id="3" name="Espace réservé des notes 2"/>
+          <p:cNvSpPr>
+            <a:spLocks noGrp="1"/>
+          </p:cNvSpPr>
+          <p:nvPr>
+            <p:ph type="body" idx="1"/>
+          </p:nvPr>
+        </p:nvSpPr>
+        <p:spPr/>
+        <p:txBody>
+          <a:bodyPr/>
+          <a:lstStyle/>
+          <a:p>
+            <a:r>
+              <a:rPr lang="fr-CH" b="1" dirty="0">
+                <a:effectLst/>
+              </a:rPr>
+              <a:t>4. Architecture générale</a:t>
+            </a:r>
+          </a:p>
+          <a:p>
+            <a:endParaRPr lang="fr-CH" b="1" dirty="0">
+              <a:effectLst/>
+            </a:endParaRPr>
+          </a:p>
+          <a:p>
+            <a:r>
+              <a:rPr lang="fr-CH" dirty="0">
+                <a:effectLst/>
+              </a:rPr>
+              <a:t>Voici le schéma global.</a:t>
+            </a:r>
+          </a:p>
+          <a:p>
+            <a:endParaRPr lang="fr-CH" dirty="0">
+              <a:effectLst/>
+            </a:endParaRPr>
+          </a:p>
+          <a:p>
+            <a:r>
+              <a:rPr lang="fr-CH" dirty="0">
+                <a:effectLst/>
+              </a:rPr>
+              <a:t>Le smartphone envoie ses données capteurs via </a:t>
+            </a:r>
+            <a:r>
+              <a:rPr lang="fr-CH" dirty="0" err="1">
+                <a:effectLst/>
+              </a:rPr>
+              <a:t>WebSocket</a:t>
+            </a:r>
+            <a:r>
+              <a:rPr lang="fr-CH" dirty="0">
+                <a:effectLst/>
+              </a:rPr>
+              <a:t> à un serveur Node.js hébergé sur Render.com. </a:t>
+            </a:r>
+          </a:p>
+          <a:p>
+            <a:endParaRPr lang="fr-CH" dirty="0">
+              <a:effectLst/>
+            </a:endParaRPr>
+          </a:p>
+          <a:p>
+            <a:r>
+              <a:rPr lang="fr-CH" dirty="0">
+                <a:effectLst/>
+              </a:rPr>
+              <a:t>Ce serveur les transmet ensuite à notre interface cockpit, qui les affiche en temps réel sous forme de widgets visuels.</a:t>
+            </a:r>
+          </a:p>
+          <a:p>
+            <a:endParaRPr lang="fr-CH" dirty="0"/>
+          </a:p>
+        </p:txBody>
+      </p:sp>
+      <p:sp>
+        <p:nvSpPr>
+          <p:cNvPr id="4" name="Espace réservé du numéro de diapositive 3"/>
+          <p:cNvSpPr>
+            <a:spLocks noGrp="1"/>
+          </p:cNvSpPr>
+          <p:nvPr>
+            <p:ph type="sldNum" sz="quarter" idx="5"/>
+          </p:nvPr>
+        </p:nvSpPr>
+        <p:spPr/>
+        <p:txBody>
+          <a:bodyPr/>
+          <a:lstStyle/>
+          <a:p>
+            <a:fld id="{71653B15-6AAF-48C6-8ACB-6499FA667B64}" type="slidenum">
+              <a:rPr lang="fr-FR" smtClean="0"/>
+              <a:t>5</a:t>
+            </a:fld>
+            <a:endParaRPr lang="fr-FR"/>
+          </a:p>
+        </p:txBody>
+      </p:sp>
+    </p:spTree>
+    <p:extLst>
+      <p:ext uri="{BB962C8B-B14F-4D97-AF65-F5344CB8AC3E}">
+        <p14:creationId xmlns:p14="http://schemas.microsoft.com/office/powerpoint/2010/main" val="2605901230"/>
+      </p:ext>
+    </p:extLst>
+  </p:cSld>
+  <p:clrMapOvr>
+    <a:masterClrMapping/>
+  </p:clrMapOvr>
+</p:notes>
+</file>
+
+<file path=ppt/notesSlides/notesSlide5.xml><?xml version="1.0" encoding="utf-8"?>
+<p:notes xmlns:a="http://schemas.openxmlformats.org/drawingml/2006/main" xmlns:r="http://schemas.openxmlformats.org/officeDocument/2006/relationships" xmlns:p="http://schemas.openxmlformats.org/presentationml/2006/main">
+  <p:cSld>
+    <p:spTree>
+      <p:nvGrpSpPr>
+        <p:cNvPr id="1" name=""/>
+        <p:cNvGrpSpPr/>
+        <p:nvPr/>
+      </p:nvGrpSpPr>
+      <p:grpSpPr>
+        <a:xfrm>
+          <a:off x="0" y="0"/>
+          <a:ext cx="0" cy="0"/>
+          <a:chOff x="0" y="0"/>
+          <a:chExt cx="0" cy="0"/>
+        </a:xfrm>
+      </p:grpSpPr>
+      <p:sp>
+        <p:nvSpPr>
+          <p:cNvPr id="2" name="Espace réservé de l'image des diapositives 1"/>
+          <p:cNvSpPr>
+            <a:spLocks noGrp="1" noRot="1" noChangeAspect="1"/>
+          </p:cNvSpPr>
+          <p:nvPr>
+            <p:ph type="sldImg"/>
+          </p:nvPr>
+        </p:nvSpPr>
+        <p:spPr/>
+      </p:sp>
+      <p:sp>
+        <p:nvSpPr>
+          <p:cNvPr id="3" name="Espace réservé des notes 2"/>
+          <p:cNvSpPr>
+            <a:spLocks noGrp="1"/>
+          </p:cNvSpPr>
+          <p:nvPr>
+            <p:ph type="body" idx="1"/>
+          </p:nvPr>
+        </p:nvSpPr>
+        <p:spPr/>
+        <p:txBody>
+          <a:bodyPr/>
+          <a:lstStyle/>
+          <a:p>
+            <a:r>
+              <a:rPr lang="fr-CH" b="1" dirty="0">
+                <a:effectLst/>
+              </a:rPr>
+              <a:t>5. Organisation du projet</a:t>
+            </a:r>
+          </a:p>
+          <a:p>
+            <a:endParaRPr lang="fr-CH" b="1" dirty="0">
+              <a:effectLst/>
+            </a:endParaRPr>
+          </a:p>
+          <a:p>
+            <a:r>
+              <a:rPr lang="fr-CH" dirty="0">
+                <a:effectLst/>
+              </a:rPr>
+              <a:t>Notre projet est structuré en modules :</a:t>
+            </a:r>
+          </a:p>
+          <a:p>
+            <a:endParaRPr lang="fr-CH" dirty="0">
+              <a:effectLst/>
+            </a:endParaRPr>
+          </a:p>
+          <a:p>
+            <a:pPr lvl="1">
+              <a:buFont typeface="Arial" panose="020B0604020202020204" pitchFamily="34" charset="0"/>
+              <a:buChar char="•"/>
+            </a:pPr>
+            <a:r>
+              <a:rPr lang="fr-CH" dirty="0">
+                <a:effectLst/>
+              </a:rPr>
+              <a:t> cockpit/ contient les widgets et le code d’affichage</a:t>
+            </a:r>
+          </a:p>
+          <a:p>
+            <a:pPr lvl="1">
+              <a:buFont typeface="Arial" panose="020B0604020202020204" pitchFamily="34" charset="0"/>
+              <a:buChar char="•"/>
+            </a:pPr>
+            <a:r>
+              <a:rPr lang="fr-CH" dirty="0">
+                <a:effectLst/>
+              </a:rPr>
+              <a:t> server/ gère les connexions </a:t>
+            </a:r>
+            <a:r>
+              <a:rPr lang="fr-CH" dirty="0" err="1">
+                <a:effectLst/>
+              </a:rPr>
+              <a:t>WebSocket</a:t>
+            </a:r>
+            <a:endParaRPr lang="fr-CH" dirty="0">
+              <a:effectLst/>
+            </a:endParaRPr>
+          </a:p>
+          <a:p>
+            <a:pPr lvl="1">
+              <a:buFont typeface="Arial" panose="020B0604020202020204" pitchFamily="34" charset="0"/>
+              <a:buChar char="•"/>
+            </a:pPr>
+            <a:r>
+              <a:rPr lang="fr-CH" dirty="0">
+                <a:effectLst/>
+              </a:rPr>
+              <a:t> smartphone/ contient le code embarqué côté mobile</a:t>
+            </a:r>
+          </a:p>
+          <a:p>
+            <a:pPr lvl="1">
+              <a:buFont typeface="Arial" panose="020B0604020202020204" pitchFamily="34" charset="0"/>
+              <a:buChar char="•"/>
+            </a:pPr>
+            <a:r>
+              <a:rPr lang="fr-CH" dirty="0">
+                <a:effectLst/>
+              </a:rPr>
+              <a:t> documents/ regroupe les livrables Chaque widget est indépendant et chargé dynamiquement.</a:t>
+            </a:r>
+          </a:p>
+          <a:p>
+            <a:endParaRPr lang="fr-CH" dirty="0"/>
+          </a:p>
+        </p:txBody>
+      </p:sp>
+      <p:sp>
+        <p:nvSpPr>
+          <p:cNvPr id="4" name="Espace réservé du numéro de diapositive 3"/>
+          <p:cNvSpPr>
+            <a:spLocks noGrp="1"/>
+          </p:cNvSpPr>
+          <p:nvPr>
+            <p:ph type="sldNum" sz="quarter" idx="5"/>
+          </p:nvPr>
+        </p:nvSpPr>
+        <p:spPr/>
+        <p:txBody>
+          <a:bodyPr/>
+          <a:lstStyle/>
+          <a:p>
+            <a:fld id="{71653B15-6AAF-48C6-8ACB-6499FA667B64}" type="slidenum">
+              <a:rPr lang="fr-FR" smtClean="0"/>
+              <a:t>6</a:t>
+            </a:fld>
+            <a:endParaRPr lang="fr-FR"/>
+          </a:p>
+        </p:txBody>
+      </p:sp>
+    </p:spTree>
+    <p:extLst>
+      <p:ext uri="{BB962C8B-B14F-4D97-AF65-F5344CB8AC3E}">
+        <p14:creationId xmlns:p14="http://schemas.microsoft.com/office/powerpoint/2010/main" val="3871856801"/>
+      </p:ext>
+    </p:extLst>
+  </p:cSld>
+  <p:clrMapOvr>
+    <a:masterClrMapping/>
+  </p:clrMapOvr>
+</p:notes>
+</file>
+
+<file path=ppt/notesSlides/notesSlide6.xml><?xml version="1.0" encoding="utf-8"?>
+<p:notes xmlns:a="http://schemas.openxmlformats.org/drawingml/2006/main" xmlns:r="http://schemas.openxmlformats.org/officeDocument/2006/relationships" xmlns:p="http://schemas.openxmlformats.org/presentationml/2006/main">
+  <p:cSld>
+    <p:spTree>
+      <p:nvGrpSpPr>
+        <p:cNvPr id="1" name=""/>
+        <p:cNvGrpSpPr/>
+        <p:nvPr/>
+      </p:nvGrpSpPr>
+      <p:grpSpPr>
+        <a:xfrm>
+          <a:off x="0" y="0"/>
+          <a:ext cx="0" cy="0"/>
+          <a:chOff x="0" y="0"/>
+          <a:chExt cx="0" cy="0"/>
+        </a:xfrm>
+      </p:grpSpPr>
+      <p:sp>
+        <p:nvSpPr>
+          <p:cNvPr id="2" name="Espace réservé de l'image des diapositives 1"/>
+          <p:cNvSpPr>
+            <a:spLocks noGrp="1" noRot="1" noChangeAspect="1"/>
+          </p:cNvSpPr>
+          <p:nvPr>
+            <p:ph type="sldImg"/>
+          </p:nvPr>
+        </p:nvSpPr>
+        <p:spPr/>
+      </p:sp>
+      <p:sp>
+        <p:nvSpPr>
+          <p:cNvPr id="3" name="Espace réservé des notes 2"/>
+          <p:cNvSpPr>
+            <a:spLocks noGrp="1"/>
+          </p:cNvSpPr>
+          <p:nvPr>
+            <p:ph type="body" idx="1"/>
+          </p:nvPr>
+        </p:nvSpPr>
+        <p:spPr/>
+        <p:txBody>
+          <a:bodyPr/>
+          <a:lstStyle/>
+          <a:p>
+            <a:r>
+              <a:rPr lang="fr-CH" b="1" dirty="0">
+                <a:effectLst/>
+              </a:rPr>
+              <a:t>6. Technologies utilisées</a:t>
+            </a:r>
+          </a:p>
+          <a:p>
+            <a:endParaRPr lang="fr-CH" b="1" dirty="0">
+              <a:effectLst/>
+            </a:endParaRPr>
+          </a:p>
+          <a:p>
+            <a:r>
+              <a:rPr lang="fr-CH" dirty="0">
+                <a:effectLst/>
+              </a:rPr>
+              <a:t>On a découvert et utilisé plusieurs technologies modernes :</a:t>
+            </a:r>
+          </a:p>
+          <a:p>
+            <a:endParaRPr lang="fr-CH" dirty="0">
+              <a:effectLst/>
+            </a:endParaRPr>
+          </a:p>
+          <a:p>
+            <a:pPr lvl="1">
+              <a:buFont typeface="Arial" panose="020B0604020202020204" pitchFamily="34" charset="0"/>
+              <a:buChar char="•"/>
+            </a:pPr>
+            <a:r>
+              <a:rPr lang="fr-CH" dirty="0">
+                <a:effectLst/>
+              </a:rPr>
+              <a:t> </a:t>
+            </a:r>
+            <a:r>
+              <a:rPr lang="fr-CH" dirty="0" err="1">
+                <a:effectLst/>
+              </a:rPr>
+              <a:t>WebSocket</a:t>
+            </a:r>
+            <a:r>
+              <a:rPr lang="fr-CH" dirty="0">
+                <a:effectLst/>
+              </a:rPr>
+              <a:t> pour le flux temps réel</a:t>
+            </a:r>
+          </a:p>
+          <a:p>
+            <a:pPr lvl="1">
+              <a:buFont typeface="Arial" panose="020B0604020202020204" pitchFamily="34" charset="0"/>
+              <a:buChar char="•"/>
+            </a:pPr>
+            <a:r>
+              <a:rPr lang="fr-CH" dirty="0">
+                <a:effectLst/>
+              </a:rPr>
+              <a:t> </a:t>
+            </a:r>
+            <a:r>
+              <a:rPr lang="fr-CH" dirty="0" err="1">
+                <a:effectLst/>
+              </a:rPr>
+              <a:t>WebRTC</a:t>
+            </a:r>
+            <a:r>
+              <a:rPr lang="fr-CH" dirty="0">
+                <a:effectLst/>
+              </a:rPr>
+              <a:t> pour le streaming vidéo</a:t>
+            </a:r>
+          </a:p>
+          <a:p>
+            <a:pPr lvl="1">
+              <a:buFont typeface="Arial" panose="020B0604020202020204" pitchFamily="34" charset="0"/>
+              <a:buChar char="•"/>
+            </a:pPr>
+            <a:r>
+              <a:rPr lang="fr-CH" dirty="0">
+                <a:effectLst/>
+              </a:rPr>
+              <a:t> Node.js pour le backend</a:t>
+            </a:r>
+          </a:p>
+          <a:p>
+            <a:pPr lvl="1">
+              <a:buFont typeface="Arial" panose="020B0604020202020204" pitchFamily="34" charset="0"/>
+              <a:buChar char="•"/>
+            </a:pPr>
+            <a:r>
+              <a:rPr lang="fr-CH" dirty="0">
+                <a:effectLst/>
+              </a:rPr>
+              <a:t> Render.com pour le déploiement cloud Et bien sûr, JavaScript pour toute la logique cockpit.</a:t>
+            </a:r>
+          </a:p>
+          <a:p>
+            <a:endParaRPr lang="fr-CH" dirty="0"/>
+          </a:p>
+        </p:txBody>
+      </p:sp>
+      <p:sp>
+        <p:nvSpPr>
+          <p:cNvPr id="4" name="Espace réservé du numéro de diapositive 3"/>
+          <p:cNvSpPr>
+            <a:spLocks noGrp="1"/>
+          </p:cNvSpPr>
+          <p:nvPr>
+            <p:ph type="sldNum" sz="quarter" idx="5"/>
+          </p:nvPr>
+        </p:nvSpPr>
+        <p:spPr/>
+        <p:txBody>
+          <a:bodyPr/>
+          <a:lstStyle/>
+          <a:p>
+            <a:fld id="{71653B15-6AAF-48C6-8ACB-6499FA667B64}" type="slidenum">
+              <a:rPr lang="fr-FR" smtClean="0"/>
+              <a:t>7</a:t>
+            </a:fld>
+            <a:endParaRPr lang="fr-FR"/>
+          </a:p>
+        </p:txBody>
+      </p:sp>
+    </p:spTree>
+    <p:extLst>
+      <p:ext uri="{BB962C8B-B14F-4D97-AF65-F5344CB8AC3E}">
+        <p14:creationId xmlns:p14="http://schemas.microsoft.com/office/powerpoint/2010/main" val="380763877"/>
+      </p:ext>
+    </p:extLst>
+  </p:cSld>
+  <p:clrMapOvr>
+    <a:masterClrMapping/>
+  </p:clrMapOvr>
+</p:notes>
+</file>
+
+<file path=ppt/notesSlides/notesSlide7.xml><?xml version="1.0" encoding="utf-8"?>
+<p:notes xmlns:a="http://schemas.openxmlformats.org/drawingml/2006/main" xmlns:r="http://schemas.openxmlformats.org/officeDocument/2006/relationships" xmlns:p="http://schemas.openxmlformats.org/presentationml/2006/main">
+  <p:cSld>
+    <p:spTree>
+      <p:nvGrpSpPr>
+        <p:cNvPr id="1" name=""/>
+        <p:cNvGrpSpPr/>
+        <p:nvPr/>
+      </p:nvGrpSpPr>
+      <p:grpSpPr>
+        <a:xfrm>
+          <a:off x="0" y="0"/>
+          <a:ext cx="0" cy="0"/>
+          <a:chOff x="0" y="0"/>
+          <a:chExt cx="0" cy="0"/>
+        </a:xfrm>
+      </p:grpSpPr>
+      <p:sp>
+        <p:nvSpPr>
+          <p:cNvPr id="2" name="Espace réservé de l'image des diapositives 1"/>
+          <p:cNvSpPr>
+            <a:spLocks noGrp="1" noRot="1" noChangeAspect="1"/>
+          </p:cNvSpPr>
+          <p:nvPr>
+            <p:ph type="sldImg"/>
+          </p:nvPr>
+        </p:nvSpPr>
+        <p:spPr/>
+      </p:sp>
+      <p:sp>
+        <p:nvSpPr>
+          <p:cNvPr id="3" name="Espace réservé des notes 2"/>
+          <p:cNvSpPr>
+            <a:spLocks noGrp="1"/>
+          </p:cNvSpPr>
+          <p:nvPr>
+            <p:ph type="body" idx="1"/>
+          </p:nvPr>
+        </p:nvSpPr>
+        <p:spPr/>
+        <p:txBody>
+          <a:bodyPr/>
+          <a:lstStyle/>
+          <a:p>
+            <a:r>
+              <a:rPr lang="fr-CH" b="1" dirty="0">
+                <a:effectLst/>
+              </a:rPr>
+              <a:t>7. Exemple de widget : </a:t>
+            </a:r>
+          </a:p>
+          <a:p>
+            <a:r>
+              <a:rPr lang="fr-CH" b="0" dirty="0">
+                <a:effectLst/>
+              </a:rPr>
+              <a:t> </a:t>
+            </a:r>
+          </a:p>
+          <a:p>
+            <a:pPr lvl="1"/>
+            <a:r>
+              <a:rPr lang="fr-CH" dirty="0">
+                <a:effectLst/>
+              </a:rPr>
+              <a:t>Voici le widget boussole. </a:t>
+            </a:r>
+          </a:p>
+          <a:p>
+            <a:pPr lvl="2"/>
+            <a:r>
+              <a:rPr lang="fr-CH" dirty="0">
+                <a:effectLst/>
+              </a:rPr>
+              <a:t>Il utilise les angles d’Euler (alpha, beta, gamma) pour calculer le </a:t>
+            </a:r>
+            <a:r>
+              <a:rPr lang="fr-CH" dirty="0" err="1">
+                <a:effectLst/>
+              </a:rPr>
+              <a:t>heading</a:t>
+            </a:r>
+            <a:r>
+              <a:rPr lang="fr-CH" dirty="0">
+                <a:effectLst/>
+              </a:rPr>
+              <a:t>. </a:t>
+            </a:r>
+          </a:p>
+          <a:p>
+            <a:pPr lvl="2"/>
+            <a:r>
+              <a:rPr lang="fr-CH" dirty="0">
+                <a:effectLst/>
+              </a:rPr>
+              <a:t>On applique un filtre LPF et une interpolation </a:t>
+            </a:r>
+            <a:r>
+              <a:rPr lang="fr-CH" dirty="0" err="1">
+                <a:effectLst/>
+              </a:rPr>
+              <a:t>shortest‑path</a:t>
+            </a:r>
+            <a:r>
+              <a:rPr lang="fr-CH" dirty="0">
+                <a:effectLst/>
+              </a:rPr>
+              <a:t> pour éviter les sauts brusques à ±180°. </a:t>
+            </a:r>
+          </a:p>
+          <a:p>
+            <a:pPr lvl="2"/>
+            <a:r>
+              <a:rPr lang="fr-CH" dirty="0">
+                <a:effectLst/>
+              </a:rPr>
+              <a:t>Le rendu est fluide et cockpit‑</a:t>
+            </a:r>
+            <a:r>
+              <a:rPr lang="fr-CH" dirty="0" err="1">
+                <a:effectLst/>
+              </a:rPr>
+              <a:t>driven</a:t>
+            </a:r>
+            <a:r>
+              <a:rPr lang="fr-CH" dirty="0">
+                <a:effectLst/>
+              </a:rPr>
+              <a:t>.</a:t>
+            </a:r>
+          </a:p>
+          <a:p>
+            <a:endParaRPr lang="fr-CH" dirty="0">
+              <a:effectLst/>
+            </a:endParaRPr>
+          </a:p>
+          <a:p>
+            <a:r>
+              <a:rPr lang="fr-CH" dirty="0">
+                <a:effectLst/>
+              </a:rPr>
+              <a:t>	Le widget carte utilise Leaflet.</a:t>
+            </a:r>
+          </a:p>
+          <a:p>
+            <a:r>
+              <a:rPr lang="fr-CH" dirty="0">
+                <a:effectLst/>
+              </a:rPr>
+              <a:t>	 	À chaque position GPS reçue, on met à jour le marqueur et on trace le chemin parcouru. </a:t>
+            </a:r>
+          </a:p>
+          <a:p>
+            <a:r>
+              <a:rPr lang="fr-CH" dirty="0">
+                <a:effectLst/>
+              </a:rPr>
+              <a:t>		On peut aussi recentrer la carte ou réinitialiser le tracé. </a:t>
+            </a:r>
+          </a:p>
+          <a:p>
+            <a:r>
+              <a:rPr lang="fr-CH" dirty="0">
+                <a:effectLst/>
+              </a:rPr>
+              <a:t>		C’est utile pour suivre un déplacement en montagne ou en mer.</a:t>
+            </a:r>
+          </a:p>
+          <a:p>
+            <a:endParaRPr lang="fr-CH" dirty="0">
+              <a:effectLst/>
+            </a:endParaRPr>
+          </a:p>
+          <a:p>
+            <a:r>
+              <a:rPr lang="fr-CH" dirty="0">
+                <a:effectLst/>
+              </a:rPr>
+              <a:t>	Le widget horloge reçoit l’heure locale du smartphone et l’affiche en temps réel. </a:t>
+            </a:r>
+          </a:p>
+          <a:p>
+            <a:r>
+              <a:rPr lang="fr-CH" dirty="0">
+                <a:effectLst/>
+              </a:rPr>
+              <a:t>		On utilise un </a:t>
+            </a:r>
+            <a:r>
+              <a:rPr lang="fr-CH" dirty="0" err="1">
+                <a:effectLst/>
+              </a:rPr>
+              <a:t>canvas</a:t>
+            </a:r>
+            <a:r>
+              <a:rPr lang="fr-CH" dirty="0">
+                <a:effectLst/>
+              </a:rPr>
+              <a:t> avec des aiguilles dessinées à partir des angles. </a:t>
+            </a:r>
+          </a:p>
+          <a:p>
+            <a:r>
+              <a:rPr lang="fr-CH" dirty="0">
+                <a:effectLst/>
+              </a:rPr>
+              <a:t>		C’est un bon exemple d’interface cockpit simple mais efficace.</a:t>
+            </a:r>
+          </a:p>
+          <a:p>
+            <a:endParaRPr lang="fr-CH" dirty="0"/>
+          </a:p>
+        </p:txBody>
+      </p:sp>
+      <p:sp>
+        <p:nvSpPr>
+          <p:cNvPr id="4" name="Espace réservé du numéro de diapositive 3"/>
+          <p:cNvSpPr>
+            <a:spLocks noGrp="1"/>
+          </p:cNvSpPr>
+          <p:nvPr>
+            <p:ph type="sldNum" sz="quarter" idx="5"/>
+          </p:nvPr>
+        </p:nvSpPr>
+        <p:spPr/>
+        <p:txBody>
+          <a:bodyPr/>
+          <a:lstStyle/>
+          <a:p>
+            <a:fld id="{71653B15-6AAF-48C6-8ACB-6499FA667B64}" type="slidenum">
+              <a:rPr lang="fr-FR" smtClean="0"/>
+              <a:t>8</a:t>
+            </a:fld>
+            <a:endParaRPr lang="fr-FR"/>
+          </a:p>
+        </p:txBody>
+      </p:sp>
+    </p:spTree>
+    <p:extLst>
+      <p:ext uri="{BB962C8B-B14F-4D97-AF65-F5344CB8AC3E}">
+        <p14:creationId xmlns:p14="http://schemas.microsoft.com/office/powerpoint/2010/main" val="1387988109"/>
+      </p:ext>
+    </p:extLst>
+  </p:cSld>
+  <p:clrMapOvr>
+    <a:masterClrMapping/>
+  </p:clrMapOvr>
+</p:notes>
+</file>
+
+<file path=ppt/notesSlides/notesSlide8.xml><?xml version="1.0" encoding="utf-8"?>
+<p:notes xmlns:a="http://schemas.openxmlformats.org/drawingml/2006/main" xmlns:r="http://schemas.openxmlformats.org/officeDocument/2006/relationships" xmlns:p="http://schemas.openxmlformats.org/presentationml/2006/main">
+  <p:cSld>
+    <p:spTree>
+      <p:nvGrpSpPr>
+        <p:cNvPr id="1" name=""/>
+        <p:cNvGrpSpPr/>
+        <p:nvPr/>
+      </p:nvGrpSpPr>
+      <p:grpSpPr>
+        <a:xfrm>
+          <a:off x="0" y="0"/>
+          <a:ext cx="0" cy="0"/>
+          <a:chOff x="0" y="0"/>
+          <a:chExt cx="0" cy="0"/>
+        </a:xfrm>
+      </p:grpSpPr>
+      <p:sp>
+        <p:nvSpPr>
+          <p:cNvPr id="2" name="Espace réservé de l'image des diapositives 1"/>
+          <p:cNvSpPr>
+            <a:spLocks noGrp="1" noRot="1" noChangeAspect="1"/>
+          </p:cNvSpPr>
+          <p:nvPr>
+            <p:ph type="sldImg"/>
+          </p:nvPr>
+        </p:nvSpPr>
+        <p:spPr/>
+      </p:sp>
+      <p:sp>
+        <p:nvSpPr>
+          <p:cNvPr id="3" name="Espace réservé des notes 2"/>
+          <p:cNvSpPr>
+            <a:spLocks noGrp="1"/>
+          </p:cNvSpPr>
+          <p:nvPr>
+            <p:ph type="body" idx="1"/>
+          </p:nvPr>
+        </p:nvSpPr>
+        <p:spPr/>
+        <p:txBody>
+          <a:bodyPr/>
+          <a:lstStyle/>
+          <a:p>
+            <a:r>
+              <a:rPr lang="fr-CH" b="1" dirty="0">
+                <a:effectLst/>
+              </a:rPr>
+              <a:t>8. Difficultés rencontrées</a:t>
+            </a:r>
+          </a:p>
+          <a:p>
+            <a:endParaRPr lang="fr-CH" dirty="0">
+              <a:effectLst/>
+            </a:endParaRPr>
+          </a:p>
+          <a:p>
+            <a:r>
+              <a:rPr lang="fr-CH" dirty="0"/>
+              <a:t>Comme tout projet ambitieux, </a:t>
+            </a:r>
+            <a:r>
+              <a:rPr lang="fr-CH" dirty="0" err="1"/>
+              <a:t>SmartCockpit</a:t>
+            </a:r>
+            <a:r>
+              <a:rPr lang="fr-CH" dirty="0"/>
+              <a:t> nous a confrontés à plusieurs défis techniques. </a:t>
+            </a:r>
+          </a:p>
+          <a:p>
+            <a:endParaRPr lang="fr-CH" dirty="0"/>
+          </a:p>
+          <a:p>
+            <a:r>
+              <a:rPr lang="fr-CH" dirty="0"/>
+              <a:t>D’abord, l’</a:t>
+            </a:r>
+            <a:r>
+              <a:rPr lang="fr-CH" b="1" dirty="0">
+                <a:effectLst/>
+              </a:rPr>
+              <a:t>instabilité des capteurs du smartphone</a:t>
+            </a:r>
+            <a:r>
+              <a:rPr lang="fr-CH" dirty="0"/>
+              <a:t> : </a:t>
+            </a:r>
+          </a:p>
+          <a:p>
+            <a:r>
+              <a:rPr lang="fr-CH" dirty="0"/>
+              <a:t>	les données sont bruitées, parfois incohérentes, et varient selon les modèles. </a:t>
+            </a:r>
+          </a:p>
+          <a:p>
+            <a:r>
+              <a:rPr lang="fr-CH" dirty="0"/>
+              <a:t>	On a dû filtrer, interpoler, et stabiliser les angles pour obtenir un rendu fiable. </a:t>
+            </a:r>
+          </a:p>
+          <a:p>
+            <a:endParaRPr lang="fr-CH" dirty="0"/>
+          </a:p>
+          <a:p>
+            <a:r>
+              <a:rPr lang="fr-CH" dirty="0"/>
+              <a:t>Ensuite, la </a:t>
+            </a:r>
+            <a:r>
+              <a:rPr lang="fr-CH" b="1" dirty="0">
+                <a:effectLst/>
+              </a:rPr>
+              <a:t>transmission en temps réel via </a:t>
+            </a:r>
+            <a:r>
+              <a:rPr lang="fr-CH" b="1" dirty="0" err="1">
+                <a:effectLst/>
+              </a:rPr>
+              <a:t>WebSocket</a:t>
+            </a:r>
+            <a:r>
+              <a:rPr lang="fr-CH" dirty="0"/>
+              <a:t> : </a:t>
+            </a:r>
+          </a:p>
+          <a:p>
+            <a:r>
+              <a:rPr lang="fr-CH" dirty="0"/>
+              <a:t>	gérer la latence, les pertes de paquets, les reconnexions, surtout en mobilité, demande une architecture robuste. </a:t>
+            </a:r>
+          </a:p>
+          <a:p>
+            <a:r>
+              <a:rPr lang="fr-CH" dirty="0"/>
+              <a:t>	Enfin, la </a:t>
+            </a:r>
+            <a:r>
+              <a:rPr lang="fr-CH" b="1" dirty="0">
+                <a:effectLst/>
+              </a:rPr>
+              <a:t>visualisation en direct</a:t>
+            </a:r>
+            <a:r>
+              <a:rPr lang="fr-CH" dirty="0"/>
+              <a:t> : afficher simultanément carte, boussole, audio, logs, widgets… sans saturer le navigateur, c’est un vrai défi d’optimisation. </a:t>
+            </a:r>
+          </a:p>
+          <a:p>
+            <a:r>
+              <a:rPr lang="fr-CH" dirty="0"/>
+              <a:t>	Ces difficultés nous ont poussés à structurer le projet de façon modulaire, cockpit‑</a:t>
+            </a:r>
+            <a:r>
+              <a:rPr lang="fr-CH" dirty="0" err="1"/>
+              <a:t>driven</a:t>
+            </a:r>
+            <a:r>
+              <a:rPr lang="fr-CH" dirty="0"/>
+              <a:t>, pour garder fluidité et clarté.</a:t>
+            </a:r>
+            <a:endParaRPr lang="fr-CH" dirty="0">
+              <a:effectLst/>
+            </a:endParaRPr>
+          </a:p>
+          <a:p>
+            <a:endParaRPr lang="fr-CH" dirty="0"/>
+          </a:p>
+        </p:txBody>
+      </p:sp>
+      <p:sp>
+        <p:nvSpPr>
+          <p:cNvPr id="4" name="Espace réservé du numéro de diapositive 3"/>
+          <p:cNvSpPr>
+            <a:spLocks noGrp="1"/>
+          </p:cNvSpPr>
+          <p:nvPr>
+            <p:ph type="sldNum" sz="quarter" idx="5"/>
+          </p:nvPr>
+        </p:nvSpPr>
+        <p:spPr/>
+        <p:txBody>
+          <a:bodyPr/>
+          <a:lstStyle/>
+          <a:p>
+            <a:fld id="{71653B15-6AAF-48C6-8ACB-6499FA667B64}" type="slidenum">
+              <a:rPr lang="fr-FR" smtClean="0"/>
+              <a:t>9</a:t>
+            </a:fld>
+            <a:endParaRPr lang="fr-FR"/>
+          </a:p>
+        </p:txBody>
+      </p:sp>
+    </p:spTree>
+    <p:extLst>
+      <p:ext uri="{BB962C8B-B14F-4D97-AF65-F5344CB8AC3E}">
+        <p14:creationId xmlns:p14="http://schemas.microsoft.com/office/powerpoint/2010/main" val="3352102303"/>
+      </p:ext>
+    </p:extLst>
+  </p:cSld>
+  <p:clrMapOvr>
+    <a:masterClrMapping/>
+  </p:clrMapOvr>
+</p:notes>
+</file>
+
+<file path=ppt/notesSlides/notesSlide9.xml><?xml version="1.0" encoding="utf-8"?>
+<p:notes xmlns:a="http://schemas.openxmlformats.org/drawingml/2006/main" xmlns:r="http://schemas.openxmlformats.org/officeDocument/2006/relationships" xmlns:p="http://schemas.openxmlformats.org/presentationml/2006/main">
+  <p:cSld>
+    <p:spTree>
+      <p:nvGrpSpPr>
+        <p:cNvPr id="1" name=""/>
+        <p:cNvGrpSpPr/>
+        <p:nvPr/>
+      </p:nvGrpSpPr>
+      <p:grpSpPr>
+        <a:xfrm>
+          <a:off x="0" y="0"/>
+          <a:ext cx="0" cy="0"/>
+          <a:chOff x="0" y="0"/>
+          <a:chExt cx="0" cy="0"/>
+        </a:xfrm>
+      </p:grpSpPr>
+      <p:sp>
+        <p:nvSpPr>
+          <p:cNvPr id="2" name="Espace réservé de l'image des diapositives 1"/>
+          <p:cNvSpPr>
+            <a:spLocks noGrp="1" noRot="1" noChangeAspect="1"/>
+          </p:cNvSpPr>
+          <p:nvPr>
+            <p:ph type="sldImg"/>
+          </p:nvPr>
+        </p:nvSpPr>
+        <p:spPr/>
+      </p:sp>
+      <p:sp>
+        <p:nvSpPr>
+          <p:cNvPr id="3" name="Espace réservé des notes 2"/>
+          <p:cNvSpPr>
+            <a:spLocks noGrp="1"/>
+          </p:cNvSpPr>
+          <p:nvPr>
+            <p:ph type="body" idx="1"/>
+          </p:nvPr>
+        </p:nvSpPr>
+        <p:spPr/>
+        <p:txBody>
+          <a:bodyPr/>
+          <a:lstStyle/>
+          <a:p>
+            <a:r>
+              <a:rPr lang="fr-CH" b="1" dirty="0">
+                <a:effectLst/>
+              </a:rPr>
+              <a:t>9. Points positifs</a:t>
+            </a:r>
+          </a:p>
+          <a:p>
+            <a:endParaRPr lang="fr-CH" b="1" dirty="0">
+              <a:effectLst/>
+            </a:endParaRPr>
+          </a:p>
+          <a:p>
+            <a:r>
+              <a:rPr lang="fr-CH" dirty="0">
+                <a:effectLst/>
+              </a:rPr>
+              <a:t>Ce projet nous a permis :</a:t>
+            </a:r>
+          </a:p>
+          <a:p>
+            <a:pPr lvl="1">
+              <a:buFont typeface="Arial" panose="020B0604020202020204" pitchFamily="34" charset="0"/>
+              <a:buChar char="•"/>
+            </a:pPr>
+            <a:r>
+              <a:rPr lang="fr-CH" dirty="0">
+                <a:effectLst/>
+              </a:rPr>
+              <a:t> de pratiquer JavaScript en profondeur</a:t>
+            </a:r>
+          </a:p>
+          <a:p>
+            <a:pPr lvl="1">
+              <a:buFont typeface="Arial" panose="020B0604020202020204" pitchFamily="34" charset="0"/>
+              <a:buChar char="•"/>
+            </a:pPr>
+            <a:r>
+              <a:rPr lang="fr-CH" dirty="0">
+                <a:effectLst/>
+              </a:rPr>
+              <a:t> de travailler en équipe sur un projet modulaire</a:t>
+            </a:r>
+          </a:p>
+          <a:p>
+            <a:pPr lvl="1">
+              <a:buFont typeface="Arial" panose="020B0604020202020204" pitchFamily="34" charset="0"/>
+              <a:buChar char="•"/>
+            </a:pPr>
+            <a:r>
+              <a:rPr lang="fr-CH" dirty="0">
+                <a:effectLst/>
+              </a:rPr>
+              <a:t> de découvrir </a:t>
+            </a:r>
+            <a:r>
+              <a:rPr lang="fr-CH" dirty="0" err="1">
+                <a:effectLst/>
+              </a:rPr>
+              <a:t>WebSocket</a:t>
+            </a:r>
+            <a:r>
+              <a:rPr lang="fr-CH" dirty="0">
+                <a:effectLst/>
+              </a:rPr>
+              <a:t>, </a:t>
+            </a:r>
+            <a:r>
+              <a:rPr lang="fr-CH" dirty="0" err="1">
+                <a:effectLst/>
+              </a:rPr>
+              <a:t>WebRTC</a:t>
+            </a:r>
+            <a:r>
+              <a:rPr lang="fr-CH" dirty="0">
+                <a:effectLst/>
+              </a:rPr>
+              <a:t>, Node.js, Render.com</a:t>
+            </a:r>
+          </a:p>
+          <a:p>
+            <a:pPr lvl="1">
+              <a:buFont typeface="Arial" panose="020B0604020202020204" pitchFamily="34" charset="0"/>
+              <a:buChar char="•"/>
+            </a:pPr>
+            <a:r>
+              <a:rPr lang="fr-CH" dirty="0">
+                <a:effectLst/>
+              </a:rPr>
+              <a:t> de comprendre le fonctionnement des capteurs mobiles Et surtout, de construire une vraie interface cockpit temps réel.</a:t>
+            </a:r>
+          </a:p>
+          <a:p>
+            <a:endParaRPr lang="fr-CH" dirty="0"/>
+          </a:p>
+        </p:txBody>
+      </p:sp>
+      <p:sp>
+        <p:nvSpPr>
+          <p:cNvPr id="4" name="Espace réservé du numéro de diapositive 3"/>
+          <p:cNvSpPr>
+            <a:spLocks noGrp="1"/>
+          </p:cNvSpPr>
+          <p:nvPr>
+            <p:ph type="sldNum" sz="quarter" idx="5"/>
+          </p:nvPr>
+        </p:nvSpPr>
+        <p:spPr/>
+        <p:txBody>
+          <a:bodyPr/>
+          <a:lstStyle/>
+          <a:p>
+            <a:fld id="{71653B15-6AAF-48C6-8ACB-6499FA667B64}" type="slidenum">
+              <a:rPr lang="fr-FR" smtClean="0"/>
+              <a:t>10</a:t>
+            </a:fld>
+            <a:endParaRPr lang="fr-FR"/>
+          </a:p>
+        </p:txBody>
+      </p:sp>
+    </p:spTree>
+    <p:extLst>
+      <p:ext uri="{BB962C8B-B14F-4D97-AF65-F5344CB8AC3E}">
+        <p14:creationId xmlns:p14="http://schemas.microsoft.com/office/powerpoint/2010/main" val="622923081"/>
       </p:ext>
     </p:extLst>
   </p:cSld>
@@ -915,7 +2694,7 @@
           <a:p>
             <a:fld id="{06137112-888A-40C4-BD31-96BD10D39A6F}" type="datetimeFigureOut">
               <a:rPr lang="fr-CH" smtClean="0"/>
-              <a:t>02.01.2026</a:t>
+              <a:t>04.01.2026</a:t>
             </a:fld>
             <a:endParaRPr lang="fr-CH"/>
           </a:p>
@@ -1115,7 +2894,7 @@
           <a:p>
             <a:fld id="{06137112-888A-40C4-BD31-96BD10D39A6F}" type="datetimeFigureOut">
               <a:rPr lang="fr-CH" smtClean="0"/>
-              <a:t>02.01.2026</a:t>
+              <a:t>04.01.2026</a:t>
             </a:fld>
             <a:endParaRPr lang="fr-CH"/>
           </a:p>
@@ -1325,7 +3104,7 @@
           <a:p>
             <a:fld id="{06137112-888A-40C4-BD31-96BD10D39A6F}" type="datetimeFigureOut">
               <a:rPr lang="fr-CH" smtClean="0"/>
-              <a:t>02.01.2026</a:t>
+              <a:t>04.01.2026</a:t>
             </a:fld>
             <a:endParaRPr lang="fr-CH"/>
           </a:p>
@@ -1525,7 +3304,7 @@
           <a:p>
             <a:fld id="{06137112-888A-40C4-BD31-96BD10D39A6F}" type="datetimeFigureOut">
               <a:rPr lang="fr-CH" smtClean="0"/>
-              <a:t>02.01.2026</a:t>
+              <a:t>04.01.2026</a:t>
             </a:fld>
             <a:endParaRPr lang="fr-CH"/>
           </a:p>
@@ -1801,7 +3580,7 @@
           <a:p>
             <a:fld id="{06137112-888A-40C4-BD31-96BD10D39A6F}" type="datetimeFigureOut">
               <a:rPr lang="fr-CH" smtClean="0"/>
-              <a:t>02.01.2026</a:t>
+              <a:t>04.01.2026</a:t>
             </a:fld>
             <a:endParaRPr lang="fr-CH"/>
           </a:p>
@@ -2069,7 +3848,7 @@
           <a:p>
             <a:fld id="{06137112-888A-40C4-BD31-96BD10D39A6F}" type="datetimeFigureOut">
               <a:rPr lang="fr-CH" smtClean="0"/>
-              <a:t>02.01.2026</a:t>
+              <a:t>04.01.2026</a:t>
             </a:fld>
             <a:endParaRPr lang="fr-CH"/>
           </a:p>
@@ -2484,7 +4263,7 @@
           <a:p>
             <a:fld id="{06137112-888A-40C4-BD31-96BD10D39A6F}" type="datetimeFigureOut">
               <a:rPr lang="fr-CH" smtClean="0"/>
-              <a:t>02.01.2026</a:t>
+              <a:t>04.01.2026</a:t>
             </a:fld>
             <a:endParaRPr lang="fr-CH"/>
           </a:p>
@@ -2626,7 +4405,7 @@
           <a:p>
             <a:fld id="{06137112-888A-40C4-BD31-96BD10D39A6F}" type="datetimeFigureOut">
               <a:rPr lang="fr-CH" smtClean="0"/>
-              <a:t>02.01.2026</a:t>
+              <a:t>04.01.2026</a:t>
             </a:fld>
             <a:endParaRPr lang="fr-CH"/>
           </a:p>
@@ -2739,7 +4518,7 @@
           <a:p>
             <a:fld id="{06137112-888A-40C4-BD31-96BD10D39A6F}" type="datetimeFigureOut">
               <a:rPr lang="fr-CH" smtClean="0"/>
-              <a:t>02.01.2026</a:t>
+              <a:t>04.01.2026</a:t>
             </a:fld>
             <a:endParaRPr lang="fr-CH"/>
           </a:p>
@@ -3052,7 +4831,7 @@
           <a:p>
             <a:fld id="{06137112-888A-40C4-BD31-96BD10D39A6F}" type="datetimeFigureOut">
               <a:rPr lang="fr-CH" smtClean="0"/>
-              <a:t>02.01.2026</a:t>
+              <a:t>04.01.2026</a:t>
             </a:fld>
             <a:endParaRPr lang="fr-CH"/>
           </a:p>
@@ -3341,7 +5120,7 @@
           <a:p>
             <a:fld id="{06137112-888A-40C4-BD31-96BD10D39A6F}" type="datetimeFigureOut">
               <a:rPr lang="fr-CH" smtClean="0"/>
-              <a:t>02.01.2026</a:t>
+              <a:t>04.01.2026</a:t>
             </a:fld>
             <a:endParaRPr lang="fr-CH"/>
           </a:p>
@@ -3593,7 +5372,7 @@
           <a:p>
             <a:fld id="{06137112-888A-40C4-BD31-96BD10D39A6F}" type="datetimeFigureOut">
               <a:rPr lang="fr-CH" smtClean="0"/>
-              <a:t>02.01.2026</a:t>
+              <a:t>04.01.2026</a:t>
             </a:fld>
             <a:endParaRPr lang="fr-CH"/>
           </a:p>
@@ -4643,9 +6422,18 @@
           <a:lstStyle/>
           <a:p>
             <a:r>
+              <a:rPr lang="fr-CH" sz="2400" dirty="0"/>
+              <a:t>🌟 </a:t>
+            </a:r>
+            <a:r>
               <a:rPr lang="fr-CH" sz="2400" b="1" dirty="0"/>
-              <a:t>Points positifs</a:t>
-            </a:r>
+              <a:t>Points positifs du projet </a:t>
+            </a:r>
+            <a:r>
+              <a:rPr lang="fr-CH" sz="2400" b="1" dirty="0" err="1"/>
+              <a:t>SmartCockpit</a:t>
+            </a:r>
+            <a:endParaRPr lang="fr-CH" sz="2400" b="1" dirty="0"/>
           </a:p>
         </p:txBody>
       </p:sp>
@@ -4663,8 +6451,8 @@
         </p:nvSpPr>
         <p:spPr>
           <a:xfrm>
-            <a:off x="765916" y="1535981"/>
-            <a:ext cx="10131563" cy="3785652"/>
+            <a:off x="236693" y="1866178"/>
+            <a:ext cx="5464553" cy="3662541"/>
           </a:xfrm>
           <a:prstGeom prst="rect">
             <a:avLst/>
@@ -4677,103 +6465,474 @@
           </a:bodyPr>
           <a:lstStyle/>
           <a:p>
-            <a:pPr marL="342900" indent="-342900">
-              <a:buFont typeface="Wingdings" panose="05000000000000000000" pitchFamily="2" charset="2"/>
-              <a:buChar char="q"/>
+            <a:r>
+              <a:rPr lang="fr-CH" sz="2400" b="1" dirty="0">
+                <a:effectLst/>
+              </a:rPr>
+              <a:t>🧠 JavaScript en pratique</a:t>
+            </a:r>
+          </a:p>
+          <a:p>
+            <a:pPr lvl="1">
+              <a:buFont typeface="Arial" panose="020B0604020202020204" pitchFamily="34" charset="0"/>
+              <a:buChar char="•"/>
             </a:pPr>
             <a:r>
+              <a:rPr lang="fr-CH" sz="2000" dirty="0">
+                <a:effectLst/>
+              </a:rPr>
+              <a:t>DOM, événements, Canvas</a:t>
+            </a:r>
+          </a:p>
+          <a:p>
+            <a:pPr lvl="1">
+              <a:buFont typeface="Arial" panose="020B0604020202020204" pitchFamily="34" charset="0"/>
+              <a:buChar char="•"/>
+            </a:pPr>
+            <a:r>
+              <a:rPr lang="fr-CH" sz="2000" dirty="0">
+                <a:effectLst/>
+              </a:rPr>
+              <a:t>Web Audio API, </a:t>
+            </a:r>
+            <a:r>
+              <a:rPr lang="fr-CH" sz="2000" dirty="0" err="1">
+                <a:effectLst/>
+              </a:rPr>
+              <a:t>WebRTC</a:t>
+            </a:r>
+            <a:r>
+              <a:rPr lang="fr-CH" sz="2000" dirty="0">
+                <a:effectLst/>
+              </a:rPr>
+              <a:t>, </a:t>
+            </a:r>
+            <a:r>
+              <a:rPr lang="fr-CH" sz="2000" dirty="0" err="1">
+                <a:effectLst/>
+              </a:rPr>
+              <a:t>WebSocket</a:t>
+            </a:r>
+            <a:endParaRPr lang="fr-CH" sz="2000" dirty="0">
+              <a:effectLst/>
+            </a:endParaRPr>
+          </a:p>
+          <a:p>
+            <a:pPr lvl="1">
+              <a:buFont typeface="Arial" panose="020B0604020202020204" pitchFamily="34" charset="0"/>
+              <a:buChar char="•"/>
+            </a:pPr>
+            <a:r>
+              <a:rPr lang="fr-CH" sz="2000" dirty="0">
+                <a:effectLst/>
+              </a:rPr>
+              <a:t>Projet cockpit‑</a:t>
+            </a:r>
+            <a:r>
+              <a:rPr lang="fr-CH" sz="2000" dirty="0" err="1">
+                <a:effectLst/>
+              </a:rPr>
+              <a:t>driven</a:t>
+            </a:r>
+            <a:r>
+              <a:rPr lang="fr-CH" sz="2000" dirty="0">
+                <a:effectLst/>
+              </a:rPr>
+              <a:t> modulaire</a:t>
+            </a:r>
+          </a:p>
+          <a:p>
+            <a:pPr lvl="1">
+              <a:buFont typeface="Arial" panose="020B0604020202020204" pitchFamily="34" charset="0"/>
+              <a:buChar char="•"/>
+            </a:pPr>
+            <a:r>
+              <a:rPr lang="fr-CH" sz="2000" dirty="0">
+                <a:effectLst/>
+              </a:rPr>
+              <a:t>Interfaces dynamiques et interactives</a:t>
+            </a:r>
+          </a:p>
+          <a:p>
+            <a:endParaRPr lang="fr-CH" sz="2400" b="1" dirty="0">
+              <a:effectLst/>
+            </a:endParaRPr>
+          </a:p>
+          <a:p>
+            <a:r>
+              <a:rPr lang="fr-CH" sz="2400" b="1" dirty="0">
+                <a:effectLst/>
+              </a:rPr>
+              <a:t>🤝 Collaboration efficace</a:t>
+            </a:r>
+          </a:p>
+          <a:p>
+            <a:pPr lvl="1">
+              <a:buFont typeface="Arial" panose="020B0604020202020204" pitchFamily="34" charset="0"/>
+              <a:buChar char="•"/>
+            </a:pPr>
+            <a:r>
+              <a:rPr lang="fr-CH" sz="2000" dirty="0">
+                <a:effectLst/>
+              </a:rPr>
+              <a:t>Répartition claire des rôles</a:t>
+            </a:r>
+          </a:p>
+          <a:p>
+            <a:pPr lvl="1">
+              <a:buFont typeface="Arial" panose="020B0604020202020204" pitchFamily="34" charset="0"/>
+              <a:buChar char="•"/>
+            </a:pPr>
+            <a:r>
+              <a:rPr lang="fr-CH" sz="2000" dirty="0">
+                <a:effectLst/>
+              </a:rPr>
+              <a:t>Intégration UI, réseau, capteurs, backend</a:t>
+            </a:r>
+          </a:p>
+          <a:p>
+            <a:pPr lvl="1">
+              <a:buFont typeface="Arial" panose="020B0604020202020204" pitchFamily="34" charset="0"/>
+              <a:buChar char="•"/>
+            </a:pPr>
+            <a:r>
+              <a:rPr lang="fr-CH" sz="2000" dirty="0">
+                <a:effectLst/>
+              </a:rPr>
+              <a:t>Communication fluide et régulière</a:t>
+            </a:r>
+          </a:p>
+          <a:p>
+            <a:pPr lvl="1">
+              <a:buFont typeface="Arial" panose="020B0604020202020204" pitchFamily="34" charset="0"/>
+              <a:buChar char="•"/>
+            </a:pPr>
+            <a:r>
+              <a:rPr lang="fr-CH" sz="2000" dirty="0">
+                <a:effectLst/>
+              </a:rPr>
+              <a:t>Travail sur un projet complexe multi‑modules</a:t>
+            </a:r>
+          </a:p>
+        </p:txBody>
+      </p:sp>
+      <p:sp>
+        <p:nvSpPr>
+          <p:cNvPr id="6" name="ZoneTexte 5">
+            <a:extLst>
+              <a:ext uri="{FF2B5EF4-FFF2-40B4-BE49-F238E27FC236}">
+                <a16:creationId xmlns:a16="http://schemas.microsoft.com/office/drawing/2014/main" id="{E72D01AC-813B-4169-B130-B2F039DC55E9}"/>
+              </a:ext>
+            </a:extLst>
+          </p:cNvPr>
+          <p:cNvSpPr txBox="1"/>
+          <p:nvPr/>
+        </p:nvSpPr>
+        <p:spPr>
+          <a:xfrm>
+            <a:off x="5341470" y="1532532"/>
+            <a:ext cx="6613837" cy="4524315"/>
+          </a:xfrm>
+          <a:prstGeom prst="rect">
+            <a:avLst/>
+          </a:prstGeom>
+          <a:noFill/>
+        </p:spPr>
+        <p:txBody>
+          <a:bodyPr wrap="square" rtlCol="0">
+            <a:spAutoFit/>
+          </a:bodyPr>
+          <a:lstStyle/>
+          <a:p>
+            <a:r>
+              <a:rPr lang="fr-CH" sz="2400" b="1" dirty="0">
+                <a:effectLst/>
+              </a:rPr>
+              <a:t>🚀 Technologies explorées</a:t>
+            </a:r>
+          </a:p>
+          <a:p>
+            <a:pPr lvl="2">
+              <a:buFont typeface="Arial" panose="020B0604020202020204" pitchFamily="34" charset="0"/>
+              <a:buChar char="•"/>
+            </a:pPr>
+            <a:r>
+              <a:rPr lang="fr-CH" sz="2000" b="1" dirty="0" err="1">
+                <a:effectLst/>
+              </a:rPr>
+              <a:t>WebSocket</a:t>
+            </a:r>
+            <a:r>
+              <a:rPr lang="fr-CH" sz="2000" dirty="0">
+                <a:effectLst/>
+              </a:rPr>
+              <a:t> : bidirectionnel, robuste, capteurs en temps réel</a:t>
+            </a:r>
+          </a:p>
+          <a:p>
+            <a:pPr lvl="2">
+              <a:buFont typeface="Arial" panose="020B0604020202020204" pitchFamily="34" charset="0"/>
+              <a:buChar char="•"/>
+            </a:pPr>
+            <a:r>
+              <a:rPr lang="fr-CH" sz="2000" b="1" dirty="0" err="1">
+                <a:effectLst/>
+              </a:rPr>
+              <a:t>WebRTC</a:t>
+            </a:r>
+            <a:r>
+              <a:rPr lang="fr-CH" sz="2000" dirty="0">
+                <a:effectLst/>
+              </a:rPr>
+              <a:t> : streaming vidéo, ICE, négociation</a:t>
+            </a:r>
+          </a:p>
+          <a:p>
+            <a:pPr lvl="2">
+              <a:buFont typeface="Arial" panose="020B0604020202020204" pitchFamily="34" charset="0"/>
+              <a:buChar char="•"/>
+            </a:pPr>
+            <a:r>
+              <a:rPr lang="fr-CH" sz="2000" b="1" dirty="0">
+                <a:effectLst/>
+              </a:rPr>
+              <a:t>Node.js</a:t>
+            </a:r>
+            <a:r>
+              <a:rPr lang="fr-CH" sz="2000" dirty="0">
+                <a:effectLst/>
+              </a:rPr>
+              <a:t> : backend léger, </a:t>
+            </a:r>
+            <a:r>
+              <a:rPr lang="fr-CH" sz="2000" dirty="0" err="1">
+                <a:effectLst/>
+              </a:rPr>
+              <a:t>WebSocket</a:t>
+            </a:r>
+            <a:r>
+              <a:rPr lang="fr-CH" sz="2000" dirty="0">
+                <a:effectLst/>
+              </a:rPr>
+              <a:t> intégré</a:t>
+            </a:r>
+          </a:p>
+          <a:p>
+            <a:pPr lvl="2">
+              <a:buFont typeface="Arial" panose="020B0604020202020204" pitchFamily="34" charset="0"/>
+              <a:buChar char="•"/>
+            </a:pPr>
+            <a:r>
+              <a:rPr lang="fr-CH" sz="2000" b="1" dirty="0">
+                <a:effectLst/>
+              </a:rPr>
+              <a:t>Render.com</a:t>
+            </a:r>
+            <a:r>
+              <a:rPr lang="fr-CH" sz="2000" dirty="0">
+                <a:effectLst/>
+              </a:rPr>
+              <a:t> : déploiement cloud, </a:t>
+            </a:r>
+            <a:r>
+              <a:rPr lang="fr-CH" sz="2000" dirty="0" err="1">
+                <a:effectLst/>
+              </a:rPr>
+              <a:t>scaling</a:t>
+            </a:r>
+            <a:r>
+              <a:rPr lang="fr-CH" sz="2000" dirty="0">
+                <a:effectLst/>
+              </a:rPr>
+              <a:t> automatique</a:t>
+            </a:r>
+          </a:p>
+          <a:p>
+            <a:pPr lvl="2"/>
+            <a:endParaRPr lang="fr-CH" sz="2000" dirty="0"/>
+          </a:p>
+          <a:p>
+            <a:r>
+              <a:rPr lang="fr-CH" sz="2400" dirty="0"/>
+              <a:t>🛠️ </a:t>
+            </a:r>
+            <a:r>
               <a:rPr lang="fr-CH" sz="2400" b="1" dirty="0"/>
-              <a:t>Pratique concrète en JS</a:t>
-            </a:r>
-          </a:p>
-          <a:p>
-            <a:pPr marL="342900" indent="-342900">
-              <a:buFont typeface="Wingdings" panose="05000000000000000000" pitchFamily="2" charset="2"/>
-              <a:buChar char="q"/>
+              <a:t>Approche cockpit‑</a:t>
+            </a:r>
+            <a:r>
+              <a:rPr lang="fr-CH" sz="2400" b="1" dirty="0" err="1"/>
+              <a:t>driven</a:t>
+            </a:r>
+            <a:endParaRPr lang="fr-CH" sz="2400" b="1" dirty="0"/>
+          </a:p>
+          <a:p>
+            <a:pPr lvl="1" eaLnBrk="0" fontAlgn="base" hangingPunct="0">
+              <a:spcBef>
+                <a:spcPct val="0"/>
+              </a:spcBef>
+              <a:spcAft>
+                <a:spcPct val="0"/>
+              </a:spcAft>
+              <a:buFontTx/>
+              <a:buChar char="•"/>
             </a:pPr>
             <a:r>
-              <a:rPr lang="fr-CH" sz="2400" b="1" dirty="0"/>
-              <a:t>Travail d’équipe</a:t>
-            </a:r>
-          </a:p>
-          <a:p>
-            <a:pPr marL="342900" indent="-342900">
-              <a:buFont typeface="Wingdings" panose="05000000000000000000" pitchFamily="2" charset="2"/>
-              <a:buChar char="q"/>
+              <a:rPr kumimoji="0" lang="fr-FR" altLang="fr-FR" sz="2000" b="0" i="0" u="none" strike="noStrike" cap="none" normalizeH="0" baseline="0" dirty="0">
+                <a:ln>
+                  <a:noFill/>
+                </a:ln>
+                <a:solidFill>
+                  <a:schemeClr val="tx1"/>
+                </a:solidFill>
+                <a:effectLst/>
+              </a:rPr>
+              <a:t>Widgets totalement indépendant</a:t>
+            </a:r>
+          </a:p>
+          <a:p>
+            <a:pPr lvl="1" eaLnBrk="0" fontAlgn="base" hangingPunct="0">
+              <a:spcBef>
+                <a:spcPct val="0"/>
+              </a:spcBef>
+              <a:spcAft>
+                <a:spcPct val="0"/>
+              </a:spcAft>
+              <a:buFontTx/>
+              <a:buChar char="•"/>
             </a:pPr>
             <a:r>
-              <a:rPr lang="fr-CH" sz="2400" b="1" dirty="0"/>
-              <a:t>Découverte de technologies nouvelles pour nous</a:t>
-            </a:r>
-          </a:p>
-          <a:p>
-            <a:pPr marL="800100" lvl="1" indent="-342900">
-              <a:buFont typeface="Wingdings" panose="05000000000000000000" pitchFamily="2" charset="2"/>
-              <a:buChar char="q"/>
+              <a:rPr kumimoji="0" lang="fr-FR" altLang="fr-FR" sz="2000" b="0" i="0" u="none" strike="noStrike" cap="none" normalizeH="0" baseline="0" dirty="0">
+                <a:ln>
+                  <a:noFill/>
+                </a:ln>
+                <a:solidFill>
+                  <a:schemeClr val="tx1"/>
+                </a:solidFill>
+                <a:effectLst/>
+              </a:rPr>
+              <a:t>API interne simple (</a:t>
+            </a:r>
+            <a:r>
+              <a:rPr kumimoji="0" lang="fr-FR" altLang="fr-FR" sz="2000" b="0" i="0" u="none" strike="noStrike" cap="none" normalizeH="0" baseline="0" dirty="0" err="1">
+                <a:ln>
+                  <a:noFill/>
+                </a:ln>
+                <a:solidFill>
+                  <a:schemeClr val="tx1"/>
+                </a:solidFill>
+                <a:effectLst/>
+              </a:rPr>
+              <a:t>updateXxx</a:t>
+            </a:r>
+            <a:r>
+              <a:rPr kumimoji="0" lang="fr-FR" altLang="fr-FR" sz="2000" b="0" i="0" u="none" strike="noStrike" cap="none" normalizeH="0" baseline="0" dirty="0">
+                <a:ln>
+                  <a:noFill/>
+                </a:ln>
+                <a:solidFill>
+                  <a:schemeClr val="tx1"/>
+                </a:solidFill>
+                <a:effectLst/>
+              </a:rPr>
+              <a:t>)</a:t>
+            </a:r>
+          </a:p>
+          <a:p>
+            <a:pPr lvl="1" eaLnBrk="0" fontAlgn="base" hangingPunct="0">
+              <a:spcBef>
+                <a:spcPct val="0"/>
+              </a:spcBef>
+              <a:spcAft>
+                <a:spcPct val="0"/>
+              </a:spcAft>
+              <a:buFontTx/>
+              <a:buChar char="•"/>
             </a:pPr>
             <a:r>
-              <a:rPr lang="fr-CH" sz="2400" b="1" dirty="0" err="1"/>
-              <a:t>Websocket</a:t>
-            </a:r>
-            <a:endParaRPr lang="fr-CH" sz="2400" b="1" dirty="0"/>
-          </a:p>
-          <a:p>
-            <a:pPr marL="800100" lvl="1" indent="-342900">
-              <a:buFont typeface="Wingdings" panose="05000000000000000000" pitchFamily="2" charset="2"/>
-              <a:buChar char="q"/>
+              <a:rPr kumimoji="0" lang="fr-FR" altLang="fr-FR" sz="2000" b="0" i="0" u="none" strike="noStrike" cap="none" normalizeH="0" baseline="0" dirty="0">
+                <a:ln>
+                  <a:noFill/>
+                </a:ln>
+                <a:solidFill>
+                  <a:schemeClr val="tx1"/>
+                </a:solidFill>
+                <a:effectLst/>
+              </a:rPr>
+              <a:t>Code clair, documenté, maintenable</a:t>
+            </a:r>
+          </a:p>
+          <a:p>
+            <a:pPr lvl="1" eaLnBrk="0" fontAlgn="base" hangingPunct="0">
+              <a:spcBef>
+                <a:spcPct val="0"/>
+              </a:spcBef>
+              <a:spcAft>
+                <a:spcPct val="0"/>
+              </a:spcAft>
+              <a:buFontTx/>
+              <a:buChar char="•"/>
             </a:pPr>
             <a:r>
-              <a:rPr lang="fr-CH" sz="2400" b="1" dirty="0" err="1"/>
-              <a:t>WebRTC</a:t>
-            </a:r>
-            <a:endParaRPr lang="fr-CH" sz="2400" b="1" dirty="0"/>
-          </a:p>
-          <a:p>
-            <a:pPr marL="800100" lvl="1" indent="-342900">
-              <a:buFont typeface="Wingdings" panose="05000000000000000000" pitchFamily="2" charset="2"/>
-              <a:buChar char="q"/>
-            </a:pPr>
-            <a:r>
-              <a:rPr lang="fr-CH" sz="2400" b="1" dirty="0"/>
-              <a:t>Node.js</a:t>
-            </a:r>
-          </a:p>
-          <a:p>
-            <a:pPr marL="800100" lvl="1" indent="-342900">
-              <a:buFont typeface="Wingdings" panose="05000000000000000000" pitchFamily="2" charset="2"/>
-              <a:buChar char="q"/>
-            </a:pPr>
-            <a:r>
-              <a:rPr lang="fr-CH" sz="2400" b="1" dirty="0"/>
-              <a:t>Render.com</a:t>
-            </a:r>
-          </a:p>
-          <a:p>
-            <a:pPr marL="342900" indent="-342900">
-              <a:buFont typeface="Wingdings" panose="05000000000000000000" pitchFamily="2" charset="2"/>
-              <a:buChar char="q"/>
-            </a:pPr>
-            <a:r>
-              <a:rPr lang="fr-CH" sz="2400" b="1" dirty="0"/>
-              <a:t>…</a:t>
-            </a:r>
-          </a:p>
-          <a:p>
-            <a:pPr marL="800100" lvl="1" indent="-342900">
-              <a:buFont typeface="Wingdings" panose="05000000000000000000" pitchFamily="2" charset="2"/>
-              <a:buChar char="q"/>
-            </a:pPr>
-            <a:r>
-              <a:rPr lang="fr-CH" sz="2400" b="1" dirty="0"/>
-              <a:t>…</a:t>
-            </a:r>
-          </a:p>
-          <a:p>
-            <a:pPr marL="800100" lvl="1" indent="-342900">
-              <a:buFont typeface="Wingdings" panose="05000000000000000000" pitchFamily="2" charset="2"/>
-              <a:buChar char="q"/>
-            </a:pPr>
-            <a:endParaRPr lang="fr-CH" sz="2400" b="1" dirty="0"/>
+              <a:rPr kumimoji="0" lang="fr-FR" altLang="fr-FR" sz="2000" b="1" i="0" u="none" strike="noStrike" cap="none" normalizeH="0" baseline="0" dirty="0" err="1">
+                <a:ln>
+                  <a:noFill/>
+                </a:ln>
+                <a:solidFill>
+                  <a:schemeClr val="tx1"/>
+                </a:solidFill>
+                <a:effectLst/>
+              </a:rPr>
+              <a:t>Séparationdes</a:t>
+            </a:r>
+            <a:r>
+              <a:rPr kumimoji="0" lang="fr-FR" altLang="fr-FR" sz="2000" b="1" i="0" u="none" strike="noStrike" cap="none" normalizeH="0" baseline="0" dirty="0">
+                <a:ln>
+                  <a:noFill/>
+                </a:ln>
+                <a:solidFill>
+                  <a:schemeClr val="tx1"/>
+                </a:solidFill>
+                <a:effectLst/>
+              </a:rPr>
+              <a:t> responsabilités </a:t>
+            </a:r>
+            <a:r>
+              <a:rPr kumimoji="0" lang="fr-FR" altLang="fr-FR" sz="2000" i="0" u="none" strike="noStrike" cap="none" normalizeH="0" baseline="0" dirty="0">
+                <a:ln>
+                  <a:noFill/>
+                </a:ln>
+                <a:solidFill>
+                  <a:schemeClr val="tx1"/>
+                </a:solidFill>
+                <a:effectLst/>
+              </a:rPr>
+              <a:t>: </a:t>
+            </a:r>
+            <a:r>
+              <a:rPr kumimoji="0" lang="fr-FR" altLang="fr-FR" sz="2000" i="0" u="none" strike="noStrike" cap="none" normalizeH="0" baseline="0" dirty="0" err="1">
+                <a:ln>
+                  <a:noFill/>
+                </a:ln>
+                <a:solidFill>
+                  <a:schemeClr val="tx1"/>
+                </a:solidFill>
+                <a:effectLst/>
+              </a:rPr>
+              <a:t>acquisition,transport</a:t>
+            </a:r>
+            <a:r>
+              <a:rPr kumimoji="0" lang="fr-FR" altLang="fr-FR" sz="2000" i="0" u="none" strike="noStrike" cap="none" normalizeH="0" baseline="0" dirty="0">
+                <a:ln>
+                  <a:noFill/>
+                </a:ln>
+                <a:solidFill>
+                  <a:schemeClr val="tx1"/>
+                </a:solidFill>
+                <a:effectLst/>
+              </a:rPr>
+              <a:t>, traitement, visualisation</a:t>
+            </a:r>
           </a:p>
         </p:txBody>
       </p:sp>
@@ -4813,153 +6972,6 @@
           <a:chExt cx="0" cy="0"/>
         </a:xfrm>
       </p:grpSpPr>
-      <p:sp>
-        <p:nvSpPr>
-          <p:cNvPr id="3" name="ZoneTexte 2">
-            <a:extLst>
-              <a:ext uri="{FF2B5EF4-FFF2-40B4-BE49-F238E27FC236}">
-                <a16:creationId xmlns:a16="http://schemas.microsoft.com/office/drawing/2014/main" id="{918438DF-CFE4-0C70-9420-BB7A63517DE3}"/>
-              </a:ext>
-            </a:extLst>
-          </p:cNvPr>
-          <p:cNvSpPr txBox="1"/>
-          <p:nvPr/>
-        </p:nvSpPr>
-        <p:spPr>
-          <a:xfrm>
-            <a:off x="8032750" y="6204155"/>
-            <a:ext cx="4031430" cy="523220"/>
-          </a:xfrm>
-          <a:prstGeom prst="rect">
-            <a:avLst/>
-          </a:prstGeom>
-          <a:noFill/>
-        </p:spPr>
-        <p:txBody>
-          <a:bodyPr wrap="square" rtlCol="0">
-            <a:spAutoFit/>
-          </a:bodyPr>
-          <a:lstStyle/>
-          <a:p>
-            <a:pPr algn="r"/>
-            <a:r>
-              <a:rPr lang="fr-CH" sz="1400" dirty="0"/>
-              <a:t>CAS-DAW Projet format du web</a:t>
-            </a:r>
-            <a:br>
-              <a:rPr lang="fr-CH" sz="1400" dirty="0"/>
-            </a:br>
-            <a:r>
-              <a:rPr lang="fr-CH" sz="1400" dirty="0"/>
-              <a:t>Dolci Marco/06.11.2025</a:t>
-            </a:r>
-          </a:p>
-        </p:txBody>
-      </p:sp>
-      <p:sp>
-        <p:nvSpPr>
-          <p:cNvPr id="5" name="ZoneTexte 4">
-            <a:extLst>
-              <a:ext uri="{FF2B5EF4-FFF2-40B4-BE49-F238E27FC236}">
-                <a16:creationId xmlns:a16="http://schemas.microsoft.com/office/drawing/2014/main" id="{2CB5A18A-EC49-39DD-5997-CB93F495AEEA}"/>
-              </a:ext>
-            </a:extLst>
-          </p:cNvPr>
-          <p:cNvSpPr txBox="1"/>
-          <p:nvPr/>
-        </p:nvSpPr>
-        <p:spPr>
-          <a:xfrm>
-            <a:off x="453494" y="870500"/>
-            <a:ext cx="10062106" cy="461665"/>
-          </a:xfrm>
-          <a:prstGeom prst="rect">
-            <a:avLst/>
-          </a:prstGeom>
-          <a:noFill/>
-        </p:spPr>
-        <p:txBody>
-          <a:bodyPr wrap="square" rtlCol="0">
-            <a:spAutoFit/>
-          </a:bodyPr>
-          <a:lstStyle/>
-          <a:p>
-            <a:r>
-              <a:rPr lang="fr-CH" sz="2400" b="1" dirty="0"/>
-              <a:t>Perspectives d’évolution</a:t>
-            </a:r>
-          </a:p>
-        </p:txBody>
-      </p:sp>
-      <p:sp>
-        <p:nvSpPr>
-          <p:cNvPr id="4" name="ZoneTexte 3">
-            <a:extLst>
-              <a:ext uri="{FF2B5EF4-FFF2-40B4-BE49-F238E27FC236}">
-                <a16:creationId xmlns:a16="http://schemas.microsoft.com/office/drawing/2014/main" id="{9325492F-2021-6352-249B-1E2D77AEE164}"/>
-              </a:ext>
-            </a:extLst>
-          </p:cNvPr>
-          <p:cNvSpPr txBox="1"/>
-          <p:nvPr/>
-        </p:nvSpPr>
-        <p:spPr>
-          <a:xfrm>
-            <a:off x="765916" y="1535981"/>
-            <a:ext cx="10131563" cy="1569660"/>
-          </a:xfrm>
-          <a:prstGeom prst="rect">
-            <a:avLst/>
-          </a:prstGeom>
-          <a:noFill/>
-        </p:spPr>
-        <p:txBody>
-          <a:bodyPr wrap="square" rtlCol="0">
-            <a:spAutoFit/>
-          </a:bodyPr>
-          <a:lstStyle/>
-          <a:p>
-            <a:pPr marL="342900" indent="-342900">
-              <a:buFont typeface="Wingdings" panose="05000000000000000000" pitchFamily="2" charset="2"/>
-              <a:buChar char="q"/>
-            </a:pPr>
-            <a:r>
-              <a:rPr lang="fr-CH" sz="2400" b="1" dirty="0"/>
-              <a:t>Amélioration du flux de données</a:t>
-            </a:r>
-          </a:p>
-          <a:p>
-            <a:pPr marL="342900" indent="-342900">
-              <a:buFont typeface="Wingdings" panose="05000000000000000000" pitchFamily="2" charset="2"/>
-              <a:buChar char="q"/>
-            </a:pPr>
-            <a:r>
-              <a:rPr lang="fr-CH" sz="2400" b="1" dirty="0"/>
-              <a:t>Plus de widgets/capteurs</a:t>
-            </a:r>
-          </a:p>
-          <a:p>
-            <a:pPr marL="342900" indent="-342900">
-              <a:buFont typeface="Wingdings" panose="05000000000000000000" pitchFamily="2" charset="2"/>
-              <a:buChar char="q"/>
-            </a:pPr>
-            <a:r>
-              <a:rPr lang="fr-CH" sz="2400" b="1" dirty="0"/>
-              <a:t>Plus d’interactions avec les widgets</a:t>
-            </a:r>
-          </a:p>
-          <a:p>
-            <a:pPr marL="342900" indent="-342900">
-              <a:buFont typeface="Wingdings" panose="05000000000000000000" pitchFamily="2" charset="2"/>
-              <a:buChar char="q"/>
-            </a:pPr>
-            <a:r>
-              <a:rPr lang="fr-CH" sz="2400" b="1" dirty="0"/>
-              <a:t>…</a:t>
-            </a:r>
-          </a:p>
-        </p:txBody>
-      </p:sp>
       <p:pic>
         <p:nvPicPr>
           <p:cNvPr id="4098" name="Picture 2" descr="727 100+ Progression Stock Illustrations, graphiques vectoriels libre de  droits et Clip Art - iStock | Croissance, Evolution, Flèche">
@@ -4975,7 +6987,8 @@
           <p:nvPr/>
         </p:nvPicPr>
         <p:blipFill rotWithShape="1">
-          <a:blip r:embed="rId2">
+          <a:blip r:embed="rId3">
+            <a:alphaModFix/>
             <a:extLst>
               <a:ext uri="{28A0092B-C50C-407E-A947-70E740481C1C}">
                 <a14:useLocalDpi xmlns:a14="http://schemas.microsoft.com/office/drawing/2010/main" val="0"/>
@@ -4989,13 +7002,12 @@
         </p:blipFill>
         <p:spPr bwMode="auto">
           <a:xfrm>
-            <a:off x="7338406" y="3006494"/>
-            <a:ext cx="3559073" cy="3048001"/>
+            <a:off x="8481848" y="3139006"/>
+            <a:ext cx="3326115" cy="2848494"/>
           </a:xfrm>
           <a:prstGeom prst="rect">
             <a:avLst/>
           </a:prstGeom>
-          <a:noFill/>
           <a:extLst>
             <a:ext uri="{909E8E84-426E-40DD-AFC4-6F175D3DCCD1}">
               <a14:hiddenFill xmlns:a14="http://schemas.microsoft.com/office/drawing/2010/main">
@@ -5007,6 +7019,181 @@
           </a:extLst>
         </p:spPr>
       </p:pic>
+      <p:sp>
+        <p:nvSpPr>
+          <p:cNvPr id="3" name="ZoneTexte 2">
+            <a:extLst>
+              <a:ext uri="{FF2B5EF4-FFF2-40B4-BE49-F238E27FC236}">
+                <a16:creationId xmlns:a16="http://schemas.microsoft.com/office/drawing/2014/main" id="{918438DF-CFE4-0C70-9420-BB7A63517DE3}"/>
+              </a:ext>
+            </a:extLst>
+          </p:cNvPr>
+          <p:cNvSpPr txBox="1"/>
+          <p:nvPr/>
+        </p:nvSpPr>
+        <p:spPr>
+          <a:xfrm>
+            <a:off x="8032750" y="6204155"/>
+            <a:ext cx="4031430" cy="523220"/>
+          </a:xfrm>
+          <a:prstGeom prst="rect">
+            <a:avLst/>
+          </a:prstGeom>
+          <a:noFill/>
+        </p:spPr>
+        <p:txBody>
+          <a:bodyPr wrap="square" rtlCol="0">
+            <a:spAutoFit/>
+          </a:bodyPr>
+          <a:lstStyle/>
+          <a:p>
+            <a:pPr algn="r"/>
+            <a:r>
+              <a:rPr lang="fr-CH" sz="1400" dirty="0"/>
+              <a:t>CAS-DAW Projet format du web</a:t>
+            </a:r>
+            <a:br>
+              <a:rPr lang="fr-CH" sz="1400" dirty="0"/>
+            </a:br>
+            <a:r>
+              <a:rPr lang="fr-CH" sz="1400" dirty="0"/>
+              <a:t>Dolci Marco/06.11.2025</a:t>
+            </a:r>
+          </a:p>
+        </p:txBody>
+      </p:sp>
+      <p:sp>
+        <p:nvSpPr>
+          <p:cNvPr id="5" name="ZoneTexte 4">
+            <a:extLst>
+              <a:ext uri="{FF2B5EF4-FFF2-40B4-BE49-F238E27FC236}">
+                <a16:creationId xmlns:a16="http://schemas.microsoft.com/office/drawing/2014/main" id="{2CB5A18A-EC49-39DD-5997-CB93F495AEEA}"/>
+              </a:ext>
+            </a:extLst>
+          </p:cNvPr>
+          <p:cNvSpPr txBox="1"/>
+          <p:nvPr/>
+        </p:nvSpPr>
+        <p:spPr>
+          <a:xfrm>
+            <a:off x="453494" y="870500"/>
+            <a:ext cx="10062106" cy="461665"/>
+          </a:xfrm>
+          <a:prstGeom prst="rect">
+            <a:avLst/>
+          </a:prstGeom>
+          <a:noFill/>
+        </p:spPr>
+        <p:txBody>
+          <a:bodyPr wrap="square" rtlCol="0">
+            <a:spAutoFit/>
+          </a:bodyPr>
+          <a:lstStyle/>
+          <a:p>
+            <a:r>
+              <a:rPr lang="fr-CH" sz="2400" b="1" dirty="0"/>
+              <a:t>Perspectives d’évolution</a:t>
+            </a:r>
+          </a:p>
+        </p:txBody>
+      </p:sp>
+      <p:sp>
+        <p:nvSpPr>
+          <p:cNvPr id="4" name="ZoneTexte 3">
+            <a:extLst>
+              <a:ext uri="{FF2B5EF4-FFF2-40B4-BE49-F238E27FC236}">
+                <a16:creationId xmlns:a16="http://schemas.microsoft.com/office/drawing/2014/main" id="{9325492F-2021-6352-249B-1E2D77AEE164}"/>
+              </a:ext>
+            </a:extLst>
+          </p:cNvPr>
+          <p:cNvSpPr txBox="1"/>
+          <p:nvPr/>
+        </p:nvSpPr>
+        <p:spPr>
+          <a:xfrm>
+            <a:off x="384037" y="1594131"/>
+            <a:ext cx="10131563" cy="2308324"/>
+          </a:xfrm>
+          <a:prstGeom prst="rect">
+            <a:avLst/>
+          </a:prstGeom>
+          <a:noFill/>
+        </p:spPr>
+        <p:txBody>
+          <a:bodyPr wrap="square" rtlCol="0">
+            <a:spAutoFit/>
+          </a:bodyPr>
+          <a:lstStyle/>
+          <a:p>
+            <a:pPr marL="342900" indent="-342900">
+              <a:buFont typeface="Wingdings" panose="05000000000000000000" pitchFamily="2" charset="2"/>
+              <a:buChar char="q"/>
+            </a:pPr>
+            <a:r>
+              <a:rPr lang="fr-CH" sz="2400" b="1" dirty="0"/>
+              <a:t>Amélioration du flux de données</a:t>
+            </a:r>
+          </a:p>
+          <a:p>
+            <a:pPr marL="342900" indent="-342900">
+              <a:buFont typeface="Wingdings" panose="05000000000000000000" pitchFamily="2" charset="2"/>
+              <a:buChar char="q"/>
+            </a:pPr>
+            <a:r>
+              <a:rPr lang="fr-CH" sz="2400" b="1" dirty="0"/>
+              <a:t>Plus de widgets/capteurs</a:t>
+            </a:r>
+          </a:p>
+          <a:p>
+            <a:pPr marL="342900" indent="-342900">
+              <a:buFont typeface="Wingdings" panose="05000000000000000000" pitchFamily="2" charset="2"/>
+              <a:buChar char="q"/>
+            </a:pPr>
+            <a:r>
+              <a:rPr lang="fr-CH" sz="2400" b="1" dirty="0"/>
+              <a:t>Plus d’interactions avec les widgets</a:t>
+            </a:r>
+          </a:p>
+          <a:p>
+            <a:pPr marL="342900" indent="-342900">
+              <a:buFont typeface="Wingdings" panose="05000000000000000000" pitchFamily="2" charset="2"/>
+              <a:buChar char="q"/>
+            </a:pPr>
+            <a:r>
+              <a:rPr lang="fr-CH" sz="2400" b="1" dirty="0"/>
+              <a:t>Extension des fonctionnalités temps réel</a:t>
+            </a:r>
+          </a:p>
+          <a:p>
+            <a:pPr marL="342900" indent="-342900">
+              <a:buFont typeface="Wingdings" panose="05000000000000000000" pitchFamily="2" charset="2"/>
+              <a:buChar char="q"/>
+            </a:pPr>
+            <a:r>
+              <a:rPr lang="fr-CH" sz="2400" b="1" dirty="0"/>
+              <a:t>Mode hors‑ligne / reprise automatique après coupure réseau</a:t>
+            </a:r>
+          </a:p>
+          <a:p>
+            <a:pPr marL="342900" indent="-342900">
+              <a:buFont typeface="Wingdings" panose="05000000000000000000" pitchFamily="2" charset="2"/>
+              <a:buChar char="q"/>
+            </a:pPr>
+            <a:r>
+              <a:rPr lang="fr-CH" sz="2400" b="1" dirty="0"/>
+              <a:t>Historique et visualisation des données (replay, graphiques, </a:t>
+            </a:r>
+            <a:r>
+              <a:rPr lang="fr-CH" sz="2400" b="1" dirty="0" err="1"/>
+              <a:t>heatmaps</a:t>
+            </a:r>
+            <a:r>
+              <a:rPr lang="fr-CH" sz="2400" b="1" dirty="0"/>
+              <a:t>)</a:t>
+            </a:r>
+          </a:p>
+        </p:txBody>
+      </p:sp>
     </p:spTree>
     <p:extLst>
       <p:ext uri="{BB962C8B-B14F-4D97-AF65-F5344CB8AC3E}">
@@ -5101,7 +7288,7 @@
           <p:nvPr/>
         </p:nvPicPr>
         <p:blipFill rotWithShape="1">
-          <a:blip r:embed="rId2">
+          <a:blip r:embed="rId3">
             <a:extLst>
               <a:ext uri="{28A0092B-C50C-407E-A947-70E740481C1C}">
                 <a14:useLocalDpi xmlns:a14="http://schemas.microsoft.com/office/drawing/2010/main" val="0"/>
@@ -5505,7 +7692,7 @@
           <p:nvPr/>
         </p:nvPicPr>
         <p:blipFill>
-          <a:blip r:embed="rId2">
+          <a:blip r:embed="rId3">
             <a:extLst>
               <a:ext uri="{28A0092B-C50C-407E-A947-70E740481C1C}">
                 <a14:useLocalDpi xmlns:a14="http://schemas.microsoft.com/office/drawing/2010/main" val="0"/>
@@ -6340,7 +8527,7 @@
           <p:nvPr/>
         </p:nvPicPr>
         <p:blipFill>
-          <a:blip r:embed="rId3">
+          <a:blip r:embed="rId4">
             <a:extLst>
               <a:ext uri="{28A0092B-C50C-407E-A947-70E740481C1C}">
                 <a14:useLocalDpi xmlns:a14="http://schemas.microsoft.com/office/drawing/2010/main" val="0"/>
@@ -6455,7 +8642,7 @@
           <p:nvPr/>
         </p:nvPicPr>
         <p:blipFill>
-          <a:blip r:embed="rId4">
+          <a:blip r:embed="rId5">
             <a:extLst>
               <a:ext uri="{28A0092B-C50C-407E-A947-70E740481C1C}">
                 <a14:useLocalDpi xmlns:a14="http://schemas.microsoft.com/office/drawing/2010/main" val="0"/>
@@ -7696,7 +9883,7 @@
           <p:nvPr/>
         </p:nvPicPr>
         <p:blipFill>
-          <a:blip r:embed="rId5">
+          <a:blip r:embed="rId6">
             <a:extLst>
               <a:ext uri="{28A0092B-C50C-407E-A947-70E740481C1C}">
                 <a14:useLocalDpi xmlns:a14="http://schemas.microsoft.com/office/drawing/2010/main" val="0"/>
@@ -8645,7 +10832,7 @@
           <p:nvPr/>
         </p:nvPicPr>
         <p:blipFill>
-          <a:blip r:embed="rId2"/>
+          <a:blip r:embed="rId3"/>
           <a:srcRect t="40412"/>
           <a:stretch>
             <a:fillRect/>
@@ -8696,7 +10883,7 @@
             <p:nvPr/>
           </p:nvPicPr>
           <p:blipFill rotWithShape="1">
-            <a:blip r:embed="rId3">
+            <a:blip r:embed="rId4">
               <a:extLst>
                 <a:ext uri="{28A0092B-C50C-407E-A947-70E740481C1C}">
                   <a14:useLocalDpi xmlns:a14="http://schemas.microsoft.com/office/drawing/2010/main" val="0"/>
@@ -8898,121 +11085,6 @@
         <p:cNvPr id="1" name="">
           <a:extLst>
             <a:ext uri="{FF2B5EF4-FFF2-40B4-BE49-F238E27FC236}">
-              <a16:creationId xmlns:a16="http://schemas.microsoft.com/office/drawing/2014/main" id="{C3B8B9DB-EB48-E8DB-F9F2-EE9100630BEA}"/>
-            </a:ext>
-          </a:extLst>
-        </p:cNvPr>
-        <p:cNvGrpSpPr/>
-        <p:nvPr/>
-      </p:nvGrpSpPr>
-      <p:grpSpPr>
-        <a:xfrm>
-          <a:off x="0" y="0"/>
-          <a:ext cx="0" cy="0"/>
-          <a:chOff x="0" y="0"/>
-          <a:chExt cx="0" cy="0"/>
-        </a:xfrm>
-      </p:grpSpPr>
-      <p:pic>
-        <p:nvPicPr>
-          <p:cNvPr id="9" name="Image 8" descr="Une image contenant logo, Graphique, Police, symbole&#10;&#10;Le contenu généré par l’IA peut être incorrect.">
-            <a:extLst>
-              <a:ext uri="{FF2B5EF4-FFF2-40B4-BE49-F238E27FC236}">
-                <a16:creationId xmlns:a16="http://schemas.microsoft.com/office/drawing/2014/main" id="{FCA77BD3-F78A-98D8-EED7-7E83B3BA5C3F}"/>
-              </a:ext>
-            </a:extLst>
-          </p:cNvPr>
-          <p:cNvPicPr>
-            <a:picLocks noChangeAspect="1"/>
-          </p:cNvPicPr>
-          <p:nvPr/>
-        </p:nvPicPr>
-        <p:blipFill>
-          <a:blip r:embed="rId2">
-            <a:extLst>
-              <a:ext uri="{28A0092B-C50C-407E-A947-70E740481C1C}">
-                <a14:useLocalDpi xmlns:a14="http://schemas.microsoft.com/office/drawing/2010/main" val="0"/>
-              </a:ext>
-            </a:extLst>
-          </a:blip>
-          <a:stretch>
-            <a:fillRect/>
-          </a:stretch>
-        </p:blipFill>
-        <p:spPr>
-          <a:xfrm>
-            <a:off x="4266039" y="1528269"/>
-            <a:ext cx="3659921" cy="3388287"/>
-          </a:xfrm>
-          <a:prstGeom prst="rect">
-            <a:avLst/>
-          </a:prstGeom>
-        </p:spPr>
-      </p:pic>
-      <p:sp>
-        <p:nvSpPr>
-          <p:cNvPr id="2" name="ZoneTexte 1">
-            <a:extLst>
-              <a:ext uri="{FF2B5EF4-FFF2-40B4-BE49-F238E27FC236}">
-                <a16:creationId xmlns:a16="http://schemas.microsoft.com/office/drawing/2014/main" id="{9913D426-DD00-213C-55E5-310E58448AA4}"/>
-              </a:ext>
-            </a:extLst>
-          </p:cNvPr>
-          <p:cNvSpPr txBox="1"/>
-          <p:nvPr/>
-        </p:nvSpPr>
-        <p:spPr>
-          <a:xfrm>
-            <a:off x="8032750" y="6204155"/>
-            <a:ext cx="4031430" cy="523220"/>
-          </a:xfrm>
-          <a:prstGeom prst="rect">
-            <a:avLst/>
-          </a:prstGeom>
-          <a:noFill/>
-        </p:spPr>
-        <p:txBody>
-          <a:bodyPr wrap="square" rtlCol="0">
-            <a:spAutoFit/>
-          </a:bodyPr>
-          <a:lstStyle/>
-          <a:p>
-            <a:pPr algn="r"/>
-            <a:r>
-              <a:rPr lang="fr-CH" sz="1400" dirty="0"/>
-              <a:t>CAS-DAW Projet JavaScript</a:t>
-            </a:r>
-            <a:br>
-              <a:rPr lang="fr-CH" sz="1400" dirty="0"/>
-            </a:br>
-            <a:r>
-              <a:rPr lang="fr-CH" sz="1400" dirty="0"/>
-              <a:t>15.01.2026</a:t>
-            </a:r>
-          </a:p>
-        </p:txBody>
-      </p:sp>
-    </p:spTree>
-    <p:extLst>
-      <p:ext uri="{BB962C8B-B14F-4D97-AF65-F5344CB8AC3E}">
-        <p14:creationId xmlns:p14="http://schemas.microsoft.com/office/powerpoint/2010/main" val="1513593764"/>
-      </p:ext>
-    </p:extLst>
-  </p:cSld>
-  <p:clrMapOvr>
-    <a:masterClrMapping/>
-  </p:clrMapOvr>
-</p:sld>
-</file>
-
-<file path=ppt/slides/slide6.xml><?xml version="1.0" encoding="utf-8"?>
-<p:sld xmlns:a="http://schemas.openxmlformats.org/drawingml/2006/main" xmlns:r="http://schemas.openxmlformats.org/officeDocument/2006/relationships" xmlns:p="http://schemas.openxmlformats.org/presentationml/2006/main">
-  <p:cSld>
-    <p:spTree>
-      <p:nvGrpSpPr>
-        <p:cNvPr id="1" name="">
-          <a:extLst>
-            <a:ext uri="{FF2B5EF4-FFF2-40B4-BE49-F238E27FC236}">
               <a16:creationId xmlns:a16="http://schemas.microsoft.com/office/drawing/2014/main" id="{3B317B1C-02F0-4CBC-2A09-7D4CA8999856}"/>
             </a:ext>
           </a:extLst>
@@ -9121,7 +11193,7 @@
           <p:nvPr/>
         </p:nvPicPr>
         <p:blipFill>
-          <a:blip r:embed="rId2">
+          <a:blip r:embed="rId3">
             <a:extLst>
               <a:ext uri="{28A0092B-C50C-407E-A947-70E740481C1C}">
                 <a14:useLocalDpi xmlns:a14="http://schemas.microsoft.com/office/drawing/2010/main" val="0"/>
@@ -9160,7 +11232,7 @@
 </p:sld>
 </file>
 
-<file path=ppt/slides/slide7.xml><?xml version="1.0" encoding="utf-8"?>
+<file path=ppt/slides/slide6.xml><?xml version="1.0" encoding="utf-8"?>
 <p:sld xmlns:a="http://schemas.openxmlformats.org/drawingml/2006/main" xmlns:r="http://schemas.openxmlformats.org/officeDocument/2006/relationships" xmlns:p="http://schemas.openxmlformats.org/presentationml/2006/main">
   <p:cSld>
     <p:spTree>
@@ -9276,7 +11348,7 @@
           <p:nvPr/>
         </p:nvPicPr>
         <p:blipFill>
-          <a:blip r:embed="rId2">
+          <a:blip r:embed="rId3">
             <a:extLst>
               <a:ext uri="{28A0092B-C50C-407E-A947-70E740481C1C}">
                 <a14:useLocalDpi xmlns:a14="http://schemas.microsoft.com/office/drawing/2010/main" val="0"/>
@@ -9312,7 +11384,7 @@
           <p:nvPr/>
         </p:nvPicPr>
         <p:blipFill>
-          <a:blip r:embed="rId3">
+          <a:blip r:embed="rId4">
             <a:extLst>
               <a:ext uri="{28A0092B-C50C-407E-A947-70E740481C1C}">
                 <a14:useLocalDpi xmlns:a14="http://schemas.microsoft.com/office/drawing/2010/main" val="0"/>
@@ -9348,7 +11420,7 @@
           <p:nvPr/>
         </p:nvPicPr>
         <p:blipFill>
-          <a:blip r:embed="rId4">
+          <a:blip r:embed="rId5">
             <a:extLst>
               <a:ext uri="{28A0092B-C50C-407E-A947-70E740481C1C}">
                 <a14:useLocalDpi xmlns:a14="http://schemas.microsoft.com/office/drawing/2010/main" val="0"/>
@@ -9384,7 +11456,7 @@
           <p:nvPr/>
         </p:nvPicPr>
         <p:blipFill>
-          <a:blip r:embed="rId5">
+          <a:blip r:embed="rId6">
             <a:extLst>
               <a:ext uri="{28A0092B-C50C-407E-A947-70E740481C1C}">
                 <a14:useLocalDpi xmlns:a14="http://schemas.microsoft.com/office/drawing/2010/main" val="0"/>
@@ -9420,7 +11492,7 @@
           <p:nvPr/>
         </p:nvPicPr>
         <p:blipFill>
-          <a:blip r:embed="rId6">
+          <a:blip r:embed="rId7">
             <a:extLst>
               <a:ext uri="{28A0092B-C50C-407E-A947-70E740481C1C}">
                 <a14:useLocalDpi xmlns:a14="http://schemas.microsoft.com/office/drawing/2010/main" val="0"/>
@@ -9456,7 +11528,7 @@
           <p:nvPr/>
         </p:nvPicPr>
         <p:blipFill>
-          <a:blip r:embed="rId7">
+          <a:blip r:embed="rId8">
             <a:extLst>
               <a:ext uri="{28A0092B-C50C-407E-A947-70E740481C1C}">
                 <a14:useLocalDpi xmlns:a14="http://schemas.microsoft.com/office/drawing/2010/main" val="0"/>
@@ -9490,7 +11562,7 @@
 </p:sld>
 </file>
 
-<file path=ppt/slides/slide8.xml><?xml version="1.0" encoding="utf-8"?>
+<file path=ppt/slides/slide7.xml><?xml version="1.0" encoding="utf-8"?>
 <p:sld xmlns:a="http://schemas.openxmlformats.org/drawingml/2006/main" xmlns:r="http://schemas.openxmlformats.org/officeDocument/2006/relationships" xmlns:p="http://schemas.openxmlformats.org/presentationml/2006/main">
   <p:cSld>
     <p:spTree>
@@ -9694,7 +11766,7 @@
           <p:nvPr/>
         </p:nvPicPr>
         <p:blipFill rotWithShape="1">
-          <a:blip r:embed="rId2">
+          <a:blip r:embed="rId3">
             <a:extLst>
               <a:ext uri="{28A0092B-C50C-407E-A947-70E740481C1C}">
                 <a14:useLocalDpi xmlns:a14="http://schemas.microsoft.com/office/drawing/2010/main" val="0"/>
@@ -9773,6 +11845,121 @@
     <p:extLst>
       <p:ext uri="{BB962C8B-B14F-4D97-AF65-F5344CB8AC3E}">
         <p14:creationId xmlns:p14="http://schemas.microsoft.com/office/powerpoint/2010/main" val="3062156110"/>
+      </p:ext>
+    </p:extLst>
+  </p:cSld>
+  <p:clrMapOvr>
+    <a:masterClrMapping/>
+  </p:clrMapOvr>
+</p:sld>
+</file>
+
+<file path=ppt/slides/slide8.xml><?xml version="1.0" encoding="utf-8"?>
+<p:sld xmlns:a="http://schemas.openxmlformats.org/drawingml/2006/main" xmlns:r="http://schemas.openxmlformats.org/officeDocument/2006/relationships" xmlns:p="http://schemas.openxmlformats.org/presentationml/2006/main">
+  <p:cSld>
+    <p:spTree>
+      <p:nvGrpSpPr>
+        <p:cNvPr id="1" name="">
+          <a:extLst>
+            <a:ext uri="{FF2B5EF4-FFF2-40B4-BE49-F238E27FC236}">
+              <a16:creationId xmlns:a16="http://schemas.microsoft.com/office/drawing/2014/main" id="{C3B8B9DB-EB48-E8DB-F9F2-EE9100630BEA}"/>
+            </a:ext>
+          </a:extLst>
+        </p:cNvPr>
+        <p:cNvGrpSpPr/>
+        <p:nvPr/>
+      </p:nvGrpSpPr>
+      <p:grpSpPr>
+        <a:xfrm>
+          <a:off x="0" y="0"/>
+          <a:ext cx="0" cy="0"/>
+          <a:chOff x="0" y="0"/>
+          <a:chExt cx="0" cy="0"/>
+        </a:xfrm>
+      </p:grpSpPr>
+      <p:pic>
+        <p:nvPicPr>
+          <p:cNvPr id="9" name="Image 8" descr="Une image contenant logo, Graphique, Police, symbole&#10;&#10;Le contenu généré par l’IA peut être incorrect.">
+            <a:extLst>
+              <a:ext uri="{FF2B5EF4-FFF2-40B4-BE49-F238E27FC236}">
+                <a16:creationId xmlns:a16="http://schemas.microsoft.com/office/drawing/2014/main" id="{FCA77BD3-F78A-98D8-EED7-7E83B3BA5C3F}"/>
+              </a:ext>
+            </a:extLst>
+          </p:cNvPr>
+          <p:cNvPicPr>
+            <a:picLocks noChangeAspect="1"/>
+          </p:cNvPicPr>
+          <p:nvPr/>
+        </p:nvPicPr>
+        <p:blipFill>
+          <a:blip r:embed="rId3">
+            <a:extLst>
+              <a:ext uri="{28A0092B-C50C-407E-A947-70E740481C1C}">
+                <a14:useLocalDpi xmlns:a14="http://schemas.microsoft.com/office/drawing/2010/main" val="0"/>
+              </a:ext>
+            </a:extLst>
+          </a:blip>
+          <a:stretch>
+            <a:fillRect/>
+          </a:stretch>
+        </p:blipFill>
+        <p:spPr>
+          <a:xfrm>
+            <a:off x="4266039" y="1528269"/>
+            <a:ext cx="3659921" cy="3388287"/>
+          </a:xfrm>
+          <a:prstGeom prst="rect">
+            <a:avLst/>
+          </a:prstGeom>
+        </p:spPr>
+      </p:pic>
+      <p:sp>
+        <p:nvSpPr>
+          <p:cNvPr id="2" name="ZoneTexte 1">
+            <a:extLst>
+              <a:ext uri="{FF2B5EF4-FFF2-40B4-BE49-F238E27FC236}">
+                <a16:creationId xmlns:a16="http://schemas.microsoft.com/office/drawing/2014/main" id="{9913D426-DD00-213C-55E5-310E58448AA4}"/>
+              </a:ext>
+            </a:extLst>
+          </p:cNvPr>
+          <p:cNvSpPr txBox="1"/>
+          <p:nvPr/>
+        </p:nvSpPr>
+        <p:spPr>
+          <a:xfrm>
+            <a:off x="8032750" y="6204155"/>
+            <a:ext cx="4031430" cy="523220"/>
+          </a:xfrm>
+          <a:prstGeom prst="rect">
+            <a:avLst/>
+          </a:prstGeom>
+          <a:noFill/>
+        </p:spPr>
+        <p:txBody>
+          <a:bodyPr wrap="square" rtlCol="0">
+            <a:spAutoFit/>
+          </a:bodyPr>
+          <a:lstStyle/>
+          <a:p>
+            <a:pPr algn="r"/>
+            <a:r>
+              <a:rPr lang="fr-CH" sz="1400" dirty="0"/>
+              <a:t>CAS-DAW Projet JavaScript</a:t>
+            </a:r>
+            <a:br>
+              <a:rPr lang="fr-CH" sz="1400" dirty="0"/>
+            </a:br>
+            <a:r>
+              <a:rPr lang="fr-CH" sz="1400" dirty="0"/>
+              <a:t>15.01.2026</a:t>
+            </a:r>
+          </a:p>
+        </p:txBody>
+      </p:sp>
+    </p:spTree>
+    <p:extLst>
+      <p:ext uri="{BB962C8B-B14F-4D97-AF65-F5344CB8AC3E}">
+        <p14:creationId xmlns:p14="http://schemas.microsoft.com/office/powerpoint/2010/main" val="1513593764"/>
       </p:ext>
     </p:extLst>
   </p:cSld>
@@ -9877,6 +12064,10 @@
           <a:lstStyle/>
           <a:p>
             <a:r>
+              <a:rPr lang="fr-CH" sz="2400" dirty="0"/>
+              <a:t>🚧 </a:t>
+            </a:r>
+            <a:r>
               <a:rPr lang="fr-CH" sz="2400" b="1" dirty="0"/>
               <a:t>Difficultés rencontrées</a:t>
             </a:r>
@@ -9897,8 +12088,8 @@
         </p:nvSpPr>
         <p:spPr>
           <a:xfrm>
-            <a:off x="765916" y="1535981"/>
-            <a:ext cx="10131563" cy="830997"/>
+            <a:off x="334007" y="1619036"/>
+            <a:ext cx="11490439" cy="4462760"/>
           </a:xfrm>
           <a:prstGeom prst="rect">
             <a:avLst/>
@@ -9917,7 +12108,43 @@
             </a:pPr>
             <a:r>
               <a:rPr lang="fr-CH" sz="2400" b="1" dirty="0"/>
-              <a:t>…</a:t>
+              <a:t>Hétérogénéité et instabilité des capteurs du smartphone</a:t>
+            </a:r>
+          </a:p>
+          <a:p>
+            <a:r>
+              <a:rPr lang="fr-CH" sz="2000" dirty="0">
+                <a:effectLst/>
+              </a:rPr>
+              <a:t>Les smartphones ne sont pas des instruments scientifiques. </a:t>
+            </a:r>
+          </a:p>
+          <a:p>
+            <a:r>
+              <a:rPr lang="fr-CH" sz="2000" dirty="0">
+                <a:effectLst/>
+              </a:rPr>
+              <a:t>Tu dois composer avec : des IMU bruitées</a:t>
+            </a:r>
+            <a:r>
+              <a:rPr lang="fr-CH" sz="2000" dirty="0"/>
+              <a:t>, </a:t>
+            </a:r>
+            <a:r>
+              <a:rPr lang="fr-CH" sz="2000" dirty="0">
+                <a:effectLst/>
+              </a:rPr>
+              <a:t>angles d’Euler discontinus</a:t>
+            </a:r>
+            <a:r>
+              <a:rPr lang="fr-CH" sz="2000" dirty="0"/>
+              <a:t>, </a:t>
+            </a:r>
+            <a:r>
+              <a:rPr lang="fr-CH" sz="2000" dirty="0">
+                <a:effectLst/>
+              </a:rPr>
+              <a:t>valeurs dépendantes de l’orientation physique du téléphone, des variations entre modèles (Android vs iPhone, marques, générations)</a:t>
             </a:r>
           </a:p>
           <a:p>
@@ -9925,10 +12152,58 @@
               <a:buFont typeface="Wingdings" panose="05000000000000000000" pitchFamily="2" charset="2"/>
               <a:buChar char="q"/>
             </a:pPr>
+            <a:endParaRPr lang="fr-CH" sz="2400" b="1" dirty="0"/>
+          </a:p>
+          <a:p>
+            <a:pPr marL="342900" indent="-342900">
+              <a:buFont typeface="Wingdings" panose="05000000000000000000" pitchFamily="2" charset="2"/>
+              <a:buChar char="q"/>
+            </a:pPr>
             <a:r>
               <a:rPr lang="fr-CH" sz="2400" b="1" dirty="0"/>
-              <a:t>…</a:t>
-            </a:r>
+              <a:t>Transmission temps réel via </a:t>
+            </a:r>
+            <a:r>
+              <a:rPr lang="fr-CH" sz="2400" b="1" dirty="0" err="1"/>
+              <a:t>WebSocket</a:t>
+            </a:r>
+            <a:endParaRPr lang="fr-CH" sz="2400" b="1" dirty="0"/>
+          </a:p>
+          <a:p>
+            <a:r>
+              <a:rPr lang="fr-CH" sz="2000" dirty="0">
+                <a:effectLst/>
+              </a:rPr>
+              <a:t>Le temps réel n’est jamais “simple” : latence variable, pertes de paquets, reconnections intempestives, débit limité en 4G/5G,messages reçus dans un ordre différent de l’envoi</a:t>
+            </a:r>
+          </a:p>
+          <a:p>
+            <a:endParaRPr lang="fr-CH" sz="2400" b="1" dirty="0"/>
+          </a:p>
+          <a:p>
+            <a:pPr marL="342900" indent="-342900">
+              <a:buFont typeface="Wingdings" panose="05000000000000000000" pitchFamily="2" charset="2"/>
+              <a:buChar char="q"/>
+            </a:pPr>
+            <a:r>
+              <a:rPr lang="fr-CH" sz="2400" b="1" dirty="0"/>
+              <a:t>Visualisation en temps réel</a:t>
+            </a:r>
+          </a:p>
+          <a:p>
+            <a:r>
+              <a:rPr lang="fr-CH" sz="2000" dirty="0">
+                <a:effectLst/>
+              </a:rPr>
+              <a:t>Afficher en continu : une carte, une boussole, une voiture 2D/3D, des graphiques audio, des logs, des widgets multiples</a:t>
+            </a:r>
+          </a:p>
+          <a:p>
+            <a:pPr marL="342900" indent="-342900">
+              <a:buFont typeface="Wingdings" panose="05000000000000000000" pitchFamily="2" charset="2"/>
+              <a:buChar char="q"/>
+            </a:pPr>
+            <a:endParaRPr lang="fr-CH" sz="2400" b="1" dirty="0"/>
           </a:p>
         </p:txBody>
       </p:sp>
@@ -9947,7 +12222,7 @@
           <p:nvPr/>
         </p:nvPicPr>
         <p:blipFill rotWithShape="1">
-          <a:blip r:embed="rId2">
+          <a:blip r:embed="rId3">
             <a:extLst>
               <a:ext uri="{28A0092B-C50C-407E-A947-70E740481C1C}">
                 <a14:useLocalDpi xmlns:a14="http://schemas.microsoft.com/office/drawing/2010/main" val="0"/>
@@ -9961,8 +12236,8 @@
         </p:blipFill>
         <p:spPr bwMode="auto">
           <a:xfrm>
-            <a:off x="7590503" y="1183601"/>
-            <a:ext cx="3195484" cy="4138418"/>
+            <a:off x="10101383" y="167408"/>
+            <a:ext cx="1929253" cy="2498543"/>
           </a:xfrm>
           <a:prstGeom prst="chord">
             <a:avLst>

</xml_diff>

<commit_message>
Ajout nom de la personne qui présente la slide
</commit_message>
<xml_diff>
--- a/documents/Presentation_JS.pptx
+++ b/documents/Presentation_JS.pptx
@@ -226,7 +226,7 @@
           <a:p>
             <a:fld id="{828A8F36-A643-4FAA-8649-965D6B1446A9}" type="datetimeFigureOut">
               <a:rPr lang="fr-FR" smtClean="0"/>
-              <a:t>04/01/2026</a:t>
+              <a:t>08/01/2026</a:t>
             </a:fld>
             <a:endParaRPr lang="fr-FR"/>
           </a:p>
@@ -403,7 +403,7 @@
           <a:p>
             <a:fld id="{2456FC83-ED93-4984-B7AA-3DB9F84FF409}" type="datetimeFigureOut">
               <a:rPr lang="fr-FR" smtClean="0"/>
-              <a:t>04/01/2026</a:t>
+              <a:t>08/01/2026</a:t>
             </a:fld>
             <a:endParaRPr lang="fr-FR"/>
           </a:p>
@@ -721,7 +721,7 @@
               <a:rPr lang="fr-CH" b="1" dirty="0">
                 <a:effectLst/>
               </a:rPr>
-              <a:t>Introduction</a:t>
+              <a:t>Introduction (MD)</a:t>
             </a:r>
           </a:p>
           <a:p>
@@ -873,7 +873,7 @@
               <a:rPr lang="fr-CH" b="1" dirty="0">
                 <a:effectLst/>
               </a:rPr>
-              <a:t>10. Perspectives d’évolution</a:t>
+              <a:t>10. Perspectives d’évolution (AAA)</a:t>
             </a:r>
           </a:p>
           <a:p>
@@ -1110,7 +1110,7 @@
               <a:rPr lang="fr-CH" b="1" dirty="0">
                 <a:effectLst/>
               </a:rPr>
-              <a:t>2. Exemples de besoins couverts</a:t>
+              <a:t>2. Exemples de besoins couverts (MD)</a:t>
             </a:r>
           </a:p>
           <a:p>
@@ -1293,7 +1293,7 @@
               <a:rPr lang="fr-CH" b="1" dirty="0">
                 <a:effectLst/>
               </a:rPr>
-              <a:t>3. Concept du projet</a:t>
+              <a:t>3. Concept du projet (MD)</a:t>
             </a:r>
           </a:p>
           <a:p>
@@ -1468,7 +1468,7 @@
               <a:rPr lang="fr-CH" b="1" dirty="0">
                 <a:effectLst/>
               </a:rPr>
-              <a:t>4. Architecture générale</a:t>
+              <a:t>4. Architecture générale (CD)</a:t>
             </a:r>
           </a:p>
           <a:p>
@@ -1611,7 +1611,7 @@
               <a:rPr lang="fr-CH" b="1" dirty="0">
                 <a:effectLst/>
               </a:rPr>
-              <a:t>5. Organisation du projet</a:t>
+              <a:t>5. Organisation du projet (CD)</a:t>
             </a:r>
           </a:p>
           <a:p>
@@ -1778,7 +1778,7 @@
               <a:rPr lang="fr-CH" b="1" dirty="0">
                 <a:effectLst/>
               </a:rPr>
-              <a:t>6. Technologies utilisées</a:t>
+              <a:t>6. Technologies utilisées  (CD)</a:t>
             </a:r>
           </a:p>
           <a:p>
@@ -1956,11 +1956,28 @@
           <a:bodyPr/>
           <a:lstStyle/>
           <a:p>
+            <a:pPr marL="0" marR="0" lvl="0" indent="0" algn="l" defTabSz="914400" rtl="0" eaLnBrk="1" fontAlgn="auto" latinLnBrk="0" hangingPunct="1">
+              <a:lnSpc>
+                <a:spcPct val="100000"/>
+              </a:lnSpc>
+              <a:spcBef>
+                <a:spcPts val="0"/>
+              </a:spcBef>
+              <a:spcAft>
+                <a:spcPts val="0"/>
+              </a:spcAft>
+              <a:buClrTx/>
+              <a:buSzTx/>
+              <a:buFontTx/>
+              <a:buNone/>
+              <a:tabLst/>
+              <a:defRPr/>
+            </a:pPr>
             <a:r>
               <a:rPr lang="fr-CH" b="1" dirty="0">
                 <a:effectLst/>
               </a:rPr>
-              <a:t>7. Exemple de widget : </a:t>
+              <a:t>7. Exemple de widget : (CHACUN SES WIDGETS)</a:t>
             </a:r>
           </a:p>
           <a:p>
@@ -2210,7 +2227,7 @@
               <a:rPr lang="fr-CH" b="1" dirty="0">
                 <a:effectLst/>
               </a:rPr>
-              <a:t>8. Difficultés rencontrées</a:t>
+              <a:t>8. Difficultés rencontrées (AAA)</a:t>
             </a:r>
           </a:p>
           <a:p>
@@ -2416,7 +2433,7 @@
               <a:rPr lang="fr-CH" b="1" dirty="0">
                 <a:effectLst/>
               </a:rPr>
-              <a:t>9. Points positifs</a:t>
+              <a:t>9. Points positifs (AAA)</a:t>
             </a:r>
           </a:p>
           <a:p>
@@ -2694,7 +2711,7 @@
           <a:p>
             <a:fld id="{06137112-888A-40C4-BD31-96BD10D39A6F}" type="datetimeFigureOut">
               <a:rPr lang="fr-CH" smtClean="0"/>
-              <a:t>04.01.2026</a:t>
+              <a:t>08.01.2026</a:t>
             </a:fld>
             <a:endParaRPr lang="fr-CH"/>
           </a:p>
@@ -2894,7 +2911,7 @@
           <a:p>
             <a:fld id="{06137112-888A-40C4-BD31-96BD10D39A6F}" type="datetimeFigureOut">
               <a:rPr lang="fr-CH" smtClean="0"/>
-              <a:t>04.01.2026</a:t>
+              <a:t>08.01.2026</a:t>
             </a:fld>
             <a:endParaRPr lang="fr-CH"/>
           </a:p>
@@ -3104,7 +3121,7 @@
           <a:p>
             <a:fld id="{06137112-888A-40C4-BD31-96BD10D39A6F}" type="datetimeFigureOut">
               <a:rPr lang="fr-CH" smtClean="0"/>
-              <a:t>04.01.2026</a:t>
+              <a:t>08.01.2026</a:t>
             </a:fld>
             <a:endParaRPr lang="fr-CH"/>
           </a:p>
@@ -3304,7 +3321,7 @@
           <a:p>
             <a:fld id="{06137112-888A-40C4-BD31-96BD10D39A6F}" type="datetimeFigureOut">
               <a:rPr lang="fr-CH" smtClean="0"/>
-              <a:t>04.01.2026</a:t>
+              <a:t>08.01.2026</a:t>
             </a:fld>
             <a:endParaRPr lang="fr-CH"/>
           </a:p>
@@ -3580,7 +3597,7 @@
           <a:p>
             <a:fld id="{06137112-888A-40C4-BD31-96BD10D39A6F}" type="datetimeFigureOut">
               <a:rPr lang="fr-CH" smtClean="0"/>
-              <a:t>04.01.2026</a:t>
+              <a:t>08.01.2026</a:t>
             </a:fld>
             <a:endParaRPr lang="fr-CH"/>
           </a:p>
@@ -3848,7 +3865,7 @@
           <a:p>
             <a:fld id="{06137112-888A-40C4-BD31-96BD10D39A6F}" type="datetimeFigureOut">
               <a:rPr lang="fr-CH" smtClean="0"/>
-              <a:t>04.01.2026</a:t>
+              <a:t>08.01.2026</a:t>
             </a:fld>
             <a:endParaRPr lang="fr-CH"/>
           </a:p>
@@ -4263,7 +4280,7 @@
           <a:p>
             <a:fld id="{06137112-888A-40C4-BD31-96BD10D39A6F}" type="datetimeFigureOut">
               <a:rPr lang="fr-CH" smtClean="0"/>
-              <a:t>04.01.2026</a:t>
+              <a:t>08.01.2026</a:t>
             </a:fld>
             <a:endParaRPr lang="fr-CH"/>
           </a:p>
@@ -4405,7 +4422,7 @@
           <a:p>
             <a:fld id="{06137112-888A-40C4-BD31-96BD10D39A6F}" type="datetimeFigureOut">
               <a:rPr lang="fr-CH" smtClean="0"/>
-              <a:t>04.01.2026</a:t>
+              <a:t>08.01.2026</a:t>
             </a:fld>
             <a:endParaRPr lang="fr-CH"/>
           </a:p>
@@ -4518,7 +4535,7 @@
           <a:p>
             <a:fld id="{06137112-888A-40C4-BD31-96BD10D39A6F}" type="datetimeFigureOut">
               <a:rPr lang="fr-CH" smtClean="0"/>
-              <a:t>04.01.2026</a:t>
+              <a:t>08.01.2026</a:t>
             </a:fld>
             <a:endParaRPr lang="fr-CH"/>
           </a:p>
@@ -4831,7 +4848,7 @@
           <a:p>
             <a:fld id="{06137112-888A-40C4-BD31-96BD10D39A6F}" type="datetimeFigureOut">
               <a:rPr lang="fr-CH" smtClean="0"/>
-              <a:t>04.01.2026</a:t>
+              <a:t>08.01.2026</a:t>
             </a:fld>
             <a:endParaRPr lang="fr-CH"/>
           </a:p>
@@ -5120,7 +5137,7 @@
           <a:p>
             <a:fld id="{06137112-888A-40C4-BD31-96BD10D39A6F}" type="datetimeFigureOut">
               <a:rPr lang="fr-CH" smtClean="0"/>
-              <a:t>04.01.2026</a:t>
+              <a:t>08.01.2026</a:t>
             </a:fld>
             <a:endParaRPr lang="fr-CH"/>
           </a:p>
@@ -5372,7 +5389,7 @@
           <a:p>
             <a:fld id="{06137112-888A-40C4-BD31-96BD10D39A6F}" type="datetimeFigureOut">
               <a:rPr lang="fr-CH" smtClean="0"/>
-              <a:t>04.01.2026</a:t>
+              <a:t>08.01.2026</a:t>
             </a:fld>
             <a:endParaRPr lang="fr-CH"/>
           </a:p>
@@ -8449,7 +8466,7 @@
         </p:spPr>
         <p:txBody>
           <a:bodyPr vert="horz" lIns="91440" tIns="45720" rIns="91440" bIns="45720" rtlCol="0" anchor="b">
-            <a:normAutofit/>
+            <a:normAutofit fontScale="92500"/>
           </a:bodyPr>
           <a:lstStyle/>
           <a:p>

</xml_diff>

<commit_message>
modif. page de titre (Nom puis prénom pour tout le monde)
</commit_message>
<xml_diff>
--- a/documents/Presentation_JS.pptx
+++ b/documents/Presentation_JS.pptx
@@ -6630,8 +6630,24 @@
                 <a:ea typeface="+mn-ea"/>
                 <a:cs typeface="+mn-cs"/>
               </a:rPr>
-              <a:t>Ayman Akram</a:t>
-            </a:r>
+              <a:t>Akram</a:t>
+            </a:r>
+            <a:r>
+              <a:rPr lang="en-US" sz="1700" dirty="0">
+                <a:solidFill>
+                  <a:schemeClr val="bg1"/>
+                </a:solidFill>
+              </a:rPr>
+              <a:t> Ayman</a:t>
+            </a:r>
+            <a:endParaRPr lang="en-US" sz="1700" kern="1200" dirty="0">
+              <a:solidFill>
+                <a:schemeClr val="bg1"/>
+              </a:solidFill>
+              <a:latin typeface="+mn-lt"/>
+              <a:ea typeface="+mn-ea"/>
+              <a:cs typeface="+mn-cs"/>
+            </a:endParaRPr>
           </a:p>
         </p:txBody>
       </p:sp>

</xml_diff>